<commit_message>
Deployed 74d68cb with MkDocs version: 1.6.1
</commit_message>
<xml_diff>
--- a/tema2/diapositivas/principios-programacion-segura.pptx
+++ b/tema2/diapositivas/principios-programacion-segura.pptx
@@ -4,6 +4,9 @@
   <p:sldMasterIdLst>
     <p:sldMasterId id="2147483648" r:id="rId1"/>
   </p:sldMasterIdLst>
+  <p:notesMasterIdLst>
+    <p:notesMasterId r:id="rId31"/>
+  </p:notesMasterIdLst>
   <p:sldIdLst>
     <p:sldId id="256" r:id="rId2"/>
     <p:sldId id="257" r:id="rId3"/>
@@ -35,9 +38,6 @@
     <p:sldId id="283" r:id="rId29"/>
     <p:sldId id="284" r:id="rId30"/>
   </p:sldIdLst>
-  <p:notesMasterIdLst>
-    <p:notesMasterId r:id="rId31"/>
-  </p:notesMasterIdLst>
   <p:sldSz cx="12192000" cy="6858000"/>
   <p:notesSz cx="6858000" cy="12192000"/>
   <p:defaultTextStyle>
@@ -132,6 +132,11 @@
       </a:defRPr>
     </a:lvl9pPr>
   </p:defaultTextStyle>
+  <p:extLst>
+    <p:ext uri="{EFAFB233-063F-42B5-8137-9DF3F51BA10A}">
+      <p15:sldGuideLst xmlns:p15="http://schemas.microsoft.com/office/powerpoint/2012/main"/>
+    </p:ext>
+  </p:extLst>
 </p:presentation>
 </file>
 
@@ -157,234 +162,10 @@
           <a:chExt cx="0" cy="0"/>
         </a:xfrm>
       </p:grpSpPr>
-      <p:sp>
-        <p:nvSpPr>
-          <p:cNvPr id="2" name="Header Placeholder 1"/>
-          <p:cNvSpPr>
-            <a:spLocks noGrp="1"/>
-          </p:cNvSpPr>
-          <p:nvPr>
-            <p:ph type="hdr" sz="quarter"/>
-          </p:nvPr>
-        </p:nvSpPr>
-        <p:spPr>
-          <a:xfrm>
-            <a:off x="0" y="0"/>
-            <a:ext cx="2971800" cy="458788"/>
-          </a:xfrm>
-          <a:prstGeom prst="rect">
-            <a:avLst/>
-          </a:prstGeom>
-        </p:spPr>
-        <p:txBody>
-          <a:bodyPr vert="horz" lIns="91440" tIns="45720" rIns="91440" bIns="45720" rtlCol="0"/>
-          <a:lstStyle>
-            <a:lvl1pPr algn="l">
-              <a:defRPr sz="1200"/>
-            </a:lvl1pPr>
-          </a:lstStyle>
-          <a:p>
-            <a:endParaRPr lang="en-US"/>
-          </a:p>
-        </p:txBody>
-      </p:sp>
-      <p:sp>
-        <p:nvSpPr>
-          <p:cNvPr id="3" name="Date Placeholder 2"/>
-          <p:cNvSpPr>
-            <a:spLocks noGrp="1"/>
-          </p:cNvSpPr>
-          <p:nvPr>
-            <p:ph type="dt" idx="1"/>
-          </p:nvPr>
-        </p:nvSpPr>
-        <p:spPr>
-          <a:xfrm>
-            <a:off x="3884613" y="0"/>
-            <a:ext cx="2971800" cy="458788"/>
-          </a:xfrm>
-          <a:prstGeom prst="rect">
-            <a:avLst/>
-          </a:prstGeom>
-        </p:spPr>
-        <p:txBody>
-          <a:bodyPr vert="horz" lIns="91440" tIns="45720" rIns="91440" bIns="45720" rtlCol="0"/>
-          <a:lstStyle>
-            <a:lvl1pPr algn="r">
-              <a:defRPr sz="1200"/>
-            </a:lvl1pPr>
-          </a:lstStyle>
-          <a:p>
-            <a:fld id="{5282F153-3F37-0F45-9E97-73ACFA13230C}" type="datetimeFigureOut">
-              <a:rPr lang="en-US"/>
-              <a:t>7/23/19</a:t>
-            </a:fld>
-            <a:endParaRPr lang="en-US"/>
-          </a:p>
-        </p:txBody>
-      </p:sp>
-      <p:sp>
-        <p:nvSpPr>
-          <p:cNvPr id="4" name="Slide Image Placeholder 3"/>
-          <p:cNvSpPr>
-            <a:spLocks noGrp="1" noRot="1" noChangeAspect="1"/>
-          </p:cNvSpPr>
-          <p:nvPr>
-            <p:ph type="sldImg" idx="2"/>
-          </p:nvPr>
-        </p:nvSpPr>
-        <p:spPr>
-          <a:xfrm>
-            <a:off x="685800" y="1143000"/>
-            <a:ext cx="5486400" cy="3086100"/>
-          </a:xfrm>
-          <a:prstGeom prst="rect">
-            <a:avLst/>
-          </a:prstGeom>
-          <a:noFill/>
-          <a:ln w="12700">
-            <a:solidFill>
-              <a:prstClr val="black"/>
-            </a:solidFill>
-          </a:ln>
-        </p:spPr>
-        <p:txBody>
-          <a:bodyPr vert="horz" lIns="91440" tIns="45720" rIns="91440" bIns="45720" rtlCol="0" anchor="ctr"/>
-          <a:lstStyle/>
-          <a:p>
-            <a:endParaRPr lang="en-US"/>
-          </a:p>
-        </p:txBody>
-      </p:sp>
-      <p:sp>
-        <p:nvSpPr>
-          <p:cNvPr id="5" name="Notes Placeholder 4"/>
-          <p:cNvSpPr>
-            <a:spLocks noGrp="1"/>
-          </p:cNvSpPr>
-          <p:nvPr>
-            <p:ph type="body" sz="quarter" idx="3"/>
-          </p:nvPr>
-        </p:nvSpPr>
-        <p:spPr>
-          <a:xfrm>
-            <a:off x="685800" y="4400550"/>
-            <a:ext cx="5486400" cy="3600450"/>
-          </a:xfrm>
-          <a:prstGeom prst="rect">
-            <a:avLst/>
-          </a:prstGeom>
-        </p:spPr>
-        <p:txBody>
-          <a:bodyPr vert="horz" lIns="91440" tIns="45720" rIns="91440" bIns="45720" rtlCol="0"/>
-          <a:lstStyle/>
-          <a:p>
-            <a:pPr lvl="0"/>
-            <a:r>
-              <a:rPr lang="en-US"/>
-              <a:t>Click to edit Master text styles</a:t>
-            </a:r>
-          </a:p>
-          <a:p>
-            <a:pPr lvl="1"/>
-            <a:r>
-              <a:rPr lang="en-US"/>
-              <a:t>Second level</a:t>
-            </a:r>
-          </a:p>
-          <a:p>
-            <a:pPr lvl="2"/>
-            <a:r>
-              <a:rPr lang="en-US"/>
-              <a:t>Third level</a:t>
-            </a:r>
-          </a:p>
-          <a:p>
-            <a:pPr lvl="3"/>
-            <a:r>
-              <a:rPr lang="en-US"/>
-              <a:t>Fourth level</a:t>
-            </a:r>
-          </a:p>
-          <a:p>
-            <a:pPr lvl="4"/>
-            <a:r>
-              <a:rPr lang="en-US"/>
-              <a:t>Fifth level</a:t>
-            </a:r>
-          </a:p>
-        </p:txBody>
-      </p:sp>
-      <p:sp>
-        <p:nvSpPr>
-          <p:cNvPr id="6" name="Footer Placeholder 5"/>
-          <p:cNvSpPr>
-            <a:spLocks noGrp="1"/>
-          </p:cNvSpPr>
-          <p:nvPr>
-            <p:ph type="ftr" sz="quarter" idx="4"/>
-          </p:nvPr>
-        </p:nvSpPr>
-        <p:spPr>
-          <a:xfrm>
-            <a:off x="0" y="8685213"/>
-            <a:ext cx="2971800" cy="458787"/>
-          </a:xfrm>
-          <a:prstGeom prst="rect">
-            <a:avLst/>
-          </a:prstGeom>
-        </p:spPr>
-        <p:txBody>
-          <a:bodyPr vert="horz" lIns="91440" tIns="45720" rIns="91440" bIns="45720" rtlCol="0" anchor="b"/>
-          <a:lstStyle>
-            <a:lvl1pPr algn="l">
-              <a:defRPr sz="1200"/>
-            </a:lvl1pPr>
-          </a:lstStyle>
-          <a:p>
-            <a:endParaRPr lang="en-US"/>
-          </a:p>
-        </p:txBody>
-      </p:sp>
-      <p:sp>
-        <p:nvSpPr>
-          <p:cNvPr id="7" name="Slide Number Placeholder 6"/>
-          <p:cNvSpPr>
-            <a:spLocks noGrp="1"/>
-          </p:cNvSpPr>
-          <p:nvPr>
-            <p:ph type="sldNum" sz="quarter" idx="5"/>
-          </p:nvPr>
-        </p:nvSpPr>
-        <p:spPr>
-          <a:xfrm>
-            <a:off x="3884613" y="8685213"/>
-            <a:ext cx="2971800" cy="458787"/>
-          </a:xfrm>
-          <a:prstGeom prst="rect">
-            <a:avLst/>
-          </a:prstGeom>
-        </p:spPr>
-        <p:txBody>
-          <a:bodyPr vert="horz" lIns="91440" tIns="45720" rIns="91440" bIns="45720" rtlCol="0" anchor="b"/>
-          <a:lstStyle>
-            <a:lvl1pPr algn="r">
-              <a:defRPr sz="1200"/>
-            </a:lvl1pPr>
-          </a:lstStyle>
-          <a:p>
-            <a:fld id="{CE5E9CC1-C706-0F49-92D6-E571CC5EEA8F}" type="slidenum">
-              <a:rPr lang="en-US"/>
-              <a:t>‹#›</a:t>
-            </a:fld>
-            <a:endParaRPr lang="en-US"/>
-          </a:p>
-        </p:txBody>
-      </p:sp>
     </p:spTree>
     <p:extLst>
       <p:ext uri="{BB962C8B-B14F-4D97-AF65-F5344CB8AC3E}">
-        <p14:creationId xmlns:p14="http://schemas.microsoft.com/office/powerpoint/2010/main" val="1024086991"/>
+        <p14:creationId xmlns:p14="http://schemas.microsoft.com/office/powerpoint/2010/main" val="3525984605"/>
       </p:ext>
     </p:extLst>
   </p:cSld>
@@ -528,10 +309,6 @@
           <a:bodyPr/>
           <a:lstStyle/>
           <a:p>
-            <a:r>
-              <a:rPr lang="en-US" dirty="0"/>
-              <a:t/>
-            </a:r>
             <a:endParaRPr lang="en-US" dirty="0"/>
           </a:p>
         </p:txBody>
@@ -616,10 +393,6 @@
           <a:bodyPr/>
           <a:lstStyle/>
           <a:p>
-            <a:r>
-              <a:rPr lang="en-US" dirty="0"/>
-              <a:t/>
-            </a:r>
             <a:endParaRPr lang="en-US" dirty="0"/>
           </a:p>
         </p:txBody>
@@ -704,10 +477,6 @@
           <a:bodyPr/>
           <a:lstStyle/>
           <a:p>
-            <a:r>
-              <a:rPr lang="en-US" dirty="0"/>
-              <a:t/>
-            </a:r>
             <a:endParaRPr lang="en-US" dirty="0"/>
           </a:p>
         </p:txBody>
@@ -792,10 +561,6 @@
           <a:bodyPr/>
           <a:lstStyle/>
           <a:p>
-            <a:r>
-              <a:rPr lang="en-US" dirty="0"/>
-              <a:t/>
-            </a:r>
             <a:endParaRPr lang="en-US" dirty="0"/>
           </a:p>
         </p:txBody>
@@ -880,10 +645,6 @@
           <a:bodyPr/>
           <a:lstStyle/>
           <a:p>
-            <a:r>
-              <a:rPr lang="en-US" dirty="0"/>
-              <a:t/>
-            </a:r>
             <a:endParaRPr lang="en-US" dirty="0"/>
           </a:p>
         </p:txBody>
@@ -968,10 +729,6 @@
           <a:bodyPr/>
           <a:lstStyle/>
           <a:p>
-            <a:r>
-              <a:rPr lang="en-US" dirty="0"/>
-              <a:t/>
-            </a:r>
             <a:endParaRPr lang="en-US" dirty="0"/>
           </a:p>
         </p:txBody>
@@ -1056,10 +813,6 @@
           <a:bodyPr/>
           <a:lstStyle/>
           <a:p>
-            <a:r>
-              <a:rPr lang="en-US" dirty="0"/>
-              <a:t/>
-            </a:r>
             <a:endParaRPr lang="en-US" dirty="0"/>
           </a:p>
         </p:txBody>
@@ -1144,10 +897,6 @@
           <a:bodyPr/>
           <a:lstStyle/>
           <a:p>
-            <a:r>
-              <a:rPr lang="en-US" dirty="0"/>
-              <a:t/>
-            </a:r>
             <a:endParaRPr lang="en-US" dirty="0"/>
           </a:p>
         </p:txBody>
@@ -1232,10 +981,6 @@
           <a:bodyPr/>
           <a:lstStyle/>
           <a:p>
-            <a:r>
-              <a:rPr lang="en-US" dirty="0"/>
-              <a:t/>
-            </a:r>
             <a:endParaRPr lang="en-US" dirty="0"/>
           </a:p>
         </p:txBody>
@@ -1320,10 +1065,6 @@
           <a:bodyPr/>
           <a:lstStyle/>
           <a:p>
-            <a:r>
-              <a:rPr lang="en-US" dirty="0"/>
-              <a:t/>
-            </a:r>
             <a:endParaRPr lang="en-US" dirty="0"/>
           </a:p>
         </p:txBody>
@@ -1408,10 +1149,6 @@
           <a:bodyPr/>
           <a:lstStyle/>
           <a:p>
-            <a:r>
-              <a:rPr lang="en-US" dirty="0"/>
-              <a:t/>
-            </a:r>
             <a:endParaRPr lang="en-US" dirty="0"/>
           </a:p>
         </p:txBody>
@@ -1496,10 +1233,6 @@
           <a:bodyPr/>
           <a:lstStyle/>
           <a:p>
-            <a:r>
-              <a:rPr lang="en-US" dirty="0"/>
-              <a:t/>
-            </a:r>
             <a:endParaRPr lang="en-US" dirty="0"/>
           </a:p>
         </p:txBody>
@@ -1584,10 +1317,6 @@
           <a:bodyPr/>
           <a:lstStyle/>
           <a:p>
-            <a:r>
-              <a:rPr lang="en-US" dirty="0"/>
-              <a:t/>
-            </a:r>
             <a:endParaRPr lang="en-US" dirty="0"/>
           </a:p>
         </p:txBody>
@@ -1672,10 +1401,6 @@
           <a:bodyPr/>
           <a:lstStyle/>
           <a:p>
-            <a:r>
-              <a:rPr lang="en-US" dirty="0"/>
-              <a:t/>
-            </a:r>
             <a:endParaRPr lang="en-US" dirty="0"/>
           </a:p>
         </p:txBody>
@@ -1760,10 +1485,6 @@
           <a:bodyPr/>
           <a:lstStyle/>
           <a:p>
-            <a:r>
-              <a:rPr lang="en-US" dirty="0"/>
-              <a:t/>
-            </a:r>
             <a:endParaRPr lang="en-US" dirty="0"/>
           </a:p>
         </p:txBody>
@@ -1848,10 +1569,6 @@
           <a:bodyPr/>
           <a:lstStyle/>
           <a:p>
-            <a:r>
-              <a:rPr lang="en-US" dirty="0"/>
-              <a:t/>
-            </a:r>
             <a:endParaRPr lang="en-US" dirty="0"/>
           </a:p>
         </p:txBody>
@@ -1936,10 +1653,6 @@
           <a:bodyPr/>
           <a:lstStyle/>
           <a:p>
-            <a:r>
-              <a:rPr lang="en-US" dirty="0"/>
-              <a:t/>
-            </a:r>
             <a:endParaRPr lang="en-US" dirty="0"/>
           </a:p>
         </p:txBody>
@@ -2024,10 +1737,6 @@
           <a:bodyPr/>
           <a:lstStyle/>
           <a:p>
-            <a:r>
-              <a:rPr lang="en-US" dirty="0"/>
-              <a:t/>
-            </a:r>
             <a:endParaRPr lang="en-US" dirty="0"/>
           </a:p>
         </p:txBody>
@@ -2112,10 +1821,6 @@
           <a:bodyPr/>
           <a:lstStyle/>
           <a:p>
-            <a:r>
-              <a:rPr lang="en-US" dirty="0"/>
-              <a:t/>
-            </a:r>
             <a:endParaRPr lang="en-US" dirty="0"/>
           </a:p>
         </p:txBody>
@@ -2200,10 +1905,6 @@
           <a:bodyPr/>
           <a:lstStyle/>
           <a:p>
-            <a:r>
-              <a:rPr lang="en-US" dirty="0"/>
-              <a:t/>
-            </a:r>
             <a:endParaRPr lang="en-US" dirty="0"/>
           </a:p>
         </p:txBody>
@@ -2288,10 +1989,6 @@
           <a:bodyPr/>
           <a:lstStyle/>
           <a:p>
-            <a:r>
-              <a:rPr lang="en-US" dirty="0"/>
-              <a:t/>
-            </a:r>
             <a:endParaRPr lang="en-US" dirty="0"/>
           </a:p>
         </p:txBody>
@@ -2376,10 +2073,6 @@
           <a:bodyPr/>
           <a:lstStyle/>
           <a:p>
-            <a:r>
-              <a:rPr lang="en-US" dirty="0"/>
-              <a:t/>
-            </a:r>
             <a:endParaRPr lang="en-US" dirty="0"/>
           </a:p>
         </p:txBody>
@@ -2464,10 +2157,6 @@
           <a:bodyPr/>
           <a:lstStyle/>
           <a:p>
-            <a:r>
-              <a:rPr lang="en-US" dirty="0"/>
-              <a:t/>
-            </a:r>
             <a:endParaRPr lang="en-US" dirty="0"/>
           </a:p>
         </p:txBody>
@@ -2552,10 +2241,6 @@
           <a:bodyPr/>
           <a:lstStyle/>
           <a:p>
-            <a:r>
-              <a:rPr lang="en-US" dirty="0"/>
-              <a:t/>
-            </a:r>
             <a:endParaRPr lang="en-US" dirty="0"/>
           </a:p>
         </p:txBody>
@@ -2640,10 +2325,6 @@
           <a:bodyPr/>
           <a:lstStyle/>
           <a:p>
-            <a:r>
-              <a:rPr lang="en-US" dirty="0"/>
-              <a:t/>
-            </a:r>
             <a:endParaRPr lang="en-US" dirty="0"/>
           </a:p>
         </p:txBody>
@@ -2728,10 +2409,6 @@
           <a:bodyPr/>
           <a:lstStyle/>
           <a:p>
-            <a:r>
-              <a:rPr lang="en-US" dirty="0"/>
-              <a:t/>
-            </a:r>
             <a:endParaRPr lang="en-US" dirty="0"/>
           </a:p>
         </p:txBody>
@@ -2816,10 +2493,6 @@
           <a:bodyPr/>
           <a:lstStyle/>
           <a:p>
-            <a:r>
-              <a:rPr lang="en-US" dirty="0"/>
-              <a:t/>
-            </a:r>
             <a:endParaRPr lang="en-US" dirty="0"/>
           </a:p>
         </p:txBody>
@@ -2904,10 +2577,6 @@
           <a:bodyPr/>
           <a:lstStyle/>
           <a:p>
-            <a:r>
-              <a:rPr lang="en-US" dirty="0"/>
-              <a:t/>
-            </a:r>
             <a:endParaRPr lang="en-US" dirty="0"/>
           </a:p>
         </p:txBody>
@@ -2992,10 +2661,6 @@
           <a:bodyPr/>
           <a:lstStyle/>
           <a:p>
-            <a:r>
-              <a:rPr lang="en-US" dirty="0"/>
-              <a:t/>
-            </a:r>
             <a:endParaRPr lang="en-US" dirty="0"/>
           </a:p>
         </p:txBody>
@@ -3069,6 +2734,11 @@
 <file path=ppt/slideMasters/slideMaster1.xml><?xml version="1.0" encoding="utf-8"?>
 <p:sldMaster xmlns:a="http://schemas.openxmlformats.org/drawingml/2006/main" xmlns:r="http://schemas.openxmlformats.org/officeDocument/2006/relationships" xmlns:p="http://schemas.openxmlformats.org/presentationml/2006/main">
   <p:cSld>
+    <p:bg>
+      <p:bgRef idx="1001">
+        <a:schemeClr val="bg1"/>
+      </p:bgRef>
+    </p:bg>
     <p:spTree>
       <p:nvGrpSpPr>
         <p:cNvPr id="1" name=""/>
@@ -3351,6 +3021,7 @@
         <a:solidFill>
           <a:srgbClr val="4E342E"/>
         </a:solidFill>
+        <a:effectLst/>
       </p:bgPr>
     </p:bg>
     <p:spTree>
@@ -3388,7 +3059,7 @@
           <a:bodyPr wrap="square" rtlCol="0" anchor="ctr"/>
           <a:lstStyle/>
           <a:p>
-            <a:pPr indent="0" marL="0">
+            <a:pPr marL="0" indent="0">
               <a:buNone/>
             </a:pPr>
             <a:r>
@@ -3427,7 +3098,7 @@
           <a:bodyPr wrap="square" rtlCol="0" anchor="ctr"/>
           <a:lstStyle/>
           <a:p>
-            <a:pPr algn="l" indent="0" marL="0">
+            <a:pPr marL="0" indent="0" algn="l">
               <a:buNone/>
             </a:pPr>
             <a:r>
@@ -3444,7 +3115,7 @@
             <a:endParaRPr lang="en-US" sz="3400" dirty="0"/>
           </a:p>
           <a:p>
-            <a:pPr algn="l" indent="0" marL="0">
+            <a:pPr marL="0" indent="0" algn="l">
               <a:buNone/>
             </a:pPr>
             <a:r>
@@ -3486,6 +3157,13 @@
             <a:prstDash val="solid"/>
           </a:ln>
         </p:spPr>
+        <p:txBody>
+          <a:bodyPr/>
+          <a:lstStyle/>
+          <a:p>
+            <a:endParaRPr lang="es-ES"/>
+          </a:p>
+        </p:txBody>
       </p:sp>
       <p:sp>
         <p:nvSpPr>
@@ -3508,7 +3186,7 @@
           <a:bodyPr wrap="square" rtlCol="0" anchor="ctr"/>
           <a:lstStyle/>
           <a:p>
-            <a:pPr indent="0" marL="0">
+            <a:pPr marL="0" indent="0">
               <a:buNone/>
             </a:pPr>
             <a:r>
@@ -3575,6 +3253,13 @@
             <a:prstDash val="solid"/>
           </a:ln>
         </p:spPr>
+        <p:txBody>
+          <a:bodyPr/>
+          <a:lstStyle/>
+          <a:p>
+            <a:endParaRPr lang="es-ES"/>
+          </a:p>
+        </p:txBody>
       </p:sp>
       <p:sp>
         <p:nvSpPr>
@@ -3597,7 +3282,7 @@
           <a:bodyPr wrap="square" rtlCol="0" anchor="ctr"/>
           <a:lstStyle/>
           <a:p>
-            <a:pPr indent="0" marL="0">
+            <a:pPr marL="0" indent="0">
               <a:buNone/>
             </a:pPr>
             <a:r>
@@ -3636,7 +3321,7 @@
           <a:bodyPr wrap="square" rtlCol="0" anchor="ctr"/>
           <a:lstStyle/>
           <a:p>
-            <a:pPr algn="r" indent="0" marL="0">
+            <a:pPr marL="0" indent="0" algn="r">
               <a:buNone/>
             </a:pPr>
             <a:r>
@@ -3678,6 +3363,13 @@
             <a:prstDash val="solid"/>
           </a:ln>
         </p:spPr>
+        <p:txBody>
+          <a:bodyPr/>
+          <a:lstStyle/>
+          <a:p>
+            <a:endParaRPr lang="es-ES"/>
+          </a:p>
+        </p:txBody>
       </p:sp>
       <p:sp>
         <p:nvSpPr>
@@ -3700,7 +3392,7 @@
           <a:bodyPr wrap="square" rtlCol="0" anchor="ctr"/>
           <a:lstStyle/>
           <a:p>
-            <a:pPr indent="0" marL="0">
+            <a:pPr marL="0" indent="0">
               <a:buNone/>
             </a:pPr>
             <a:r>
@@ -3767,6 +3459,13 @@
             <a:prstDash val="solid"/>
           </a:ln>
         </p:spPr>
+        <p:txBody>
+          <a:bodyPr/>
+          <a:lstStyle/>
+          <a:p>
+            <a:endParaRPr lang="es-ES"/>
+          </a:p>
+        </p:txBody>
       </p:sp>
       <p:sp>
         <p:nvSpPr>
@@ -3789,7 +3488,7 @@
           <a:bodyPr wrap="square" rtlCol="0" anchor="ctr"/>
           <a:lstStyle/>
           <a:p>
-            <a:pPr indent="0" marL="0">
+            <a:pPr marL="0" indent="0">
               <a:buNone/>
             </a:pPr>
             <a:r>
@@ -3828,7 +3527,7 @@
           <a:bodyPr wrap="square" rtlCol="0" anchor="ctr"/>
           <a:lstStyle/>
           <a:p>
-            <a:pPr algn="r" indent="0" marL="0">
+            <a:pPr marL="0" indent="0" algn="r">
               <a:buNone/>
             </a:pPr>
             <a:r>
@@ -3867,7 +3566,7 @@
           <a:bodyPr wrap="square" rtlCol="0" anchor="t"/>
           <a:lstStyle/>
           <a:p>
-            <a:pPr indent="0" marL="0">
+            <a:pPr marL="0" indent="0">
               <a:buNone/>
             </a:pPr>
             <a:r>
@@ -3909,6 +3608,13 @@
             <a:prstDash val="solid"/>
           </a:ln>
         </p:spPr>
+        <p:txBody>
+          <a:bodyPr/>
+          <a:lstStyle/>
+          <a:p>
+            <a:endParaRPr lang="es-ES"/>
+          </a:p>
+        </p:txBody>
       </p:sp>
       <p:sp>
         <p:nvSpPr>
@@ -3934,6 +3640,13 @@
             <a:prstDash val="solid"/>
           </a:ln>
         </p:spPr>
+        <p:txBody>
+          <a:bodyPr/>
+          <a:lstStyle/>
+          <a:p>
+            <a:endParaRPr lang="es-ES"/>
+          </a:p>
+        </p:txBody>
       </p:sp>
       <p:sp>
         <p:nvSpPr>
@@ -3956,7 +3669,7 @@
           <a:bodyPr wrap="square" rtlCol="0" anchor="t"/>
           <a:lstStyle/>
           <a:p>
-            <a:pPr indent="0" marL="0">
+            <a:pPr marL="0" indent="0">
               <a:buNone/>
             </a:pPr>
             <a:r>
@@ -3973,7 +3686,7 @@
             <a:endParaRPr lang="en-US" sz="1350" dirty="0"/>
           </a:p>
           <a:p>
-            <a:pPr indent="0" marL="0">
+            <a:pPr marL="0" indent="0">
               <a:buNone/>
             </a:pPr>
             <a:r>
@@ -3990,7 +3703,7 @@
             <a:endParaRPr lang="en-US" sz="1350" dirty="0"/>
           </a:p>
           <a:p>
-            <a:pPr indent="0" marL="0">
+            <a:pPr marL="0" indent="0">
               <a:buNone/>
             </a:pPr>
             <a:r>
@@ -4007,7 +3720,7 @@
             <a:endParaRPr lang="en-US" sz="1350" dirty="0"/>
           </a:p>
           <a:p>
-            <a:pPr indent="0" marL="0">
+            <a:pPr marL="0" indent="0">
               <a:buNone/>
             </a:pPr>
             <a:r>
@@ -4024,13 +3737,13 @@
             <a:endParaRPr lang="en-US" sz="1350" dirty="0"/>
           </a:p>
           <a:p>
-            <a:pPr indent="0" marL="0">
+            <a:pPr marL="0" indent="0">
               <a:buNone/>
             </a:pPr>
             <a:endParaRPr lang="en-US" sz="1350" dirty="0"/>
           </a:p>
           <a:p>
-            <a:pPr indent="0" marL="0">
+            <a:pPr marL="0" indent="0">
               <a:buNone/>
             </a:pPr>
             <a:r>
@@ -4047,7 +3760,7 @@
             <a:endParaRPr lang="en-US" sz="1350" dirty="0"/>
           </a:p>
           <a:p>
-            <a:pPr indent="0" marL="0">
+            <a:pPr marL="0" indent="0">
               <a:buNone/>
             </a:pPr>
             <a:r>
@@ -4064,7 +3777,7 @@
             <a:endParaRPr lang="en-US" sz="1350" dirty="0"/>
           </a:p>
           <a:p>
-            <a:pPr indent="0" marL="0">
+            <a:pPr marL="0" indent="0">
               <a:buNone/>
             </a:pPr>
             <a:r>
@@ -4081,7 +3794,7 @@
             <a:endParaRPr lang="en-US" sz="1350" dirty="0"/>
           </a:p>
           <a:p>
-            <a:pPr indent="0" marL="0">
+            <a:pPr marL="0" indent="0">
               <a:buNone/>
             </a:pPr>
             <a:r>
@@ -4098,7 +3811,7 @@
             <a:endParaRPr lang="en-US" sz="1350" dirty="0"/>
           </a:p>
           <a:p>
-            <a:pPr indent="0" marL="0">
+            <a:pPr marL="0" indent="0">
               <a:buNone/>
             </a:pPr>
             <a:r>
@@ -4165,6 +3878,13 @@
             <a:prstDash val="solid"/>
           </a:ln>
         </p:spPr>
+        <p:txBody>
+          <a:bodyPr/>
+          <a:lstStyle/>
+          <a:p>
+            <a:endParaRPr lang="es-ES"/>
+          </a:p>
+        </p:txBody>
       </p:sp>
       <p:sp>
         <p:nvSpPr>
@@ -4187,7 +3907,7 @@
           <a:bodyPr wrap="square" rtlCol="0" anchor="ctr"/>
           <a:lstStyle/>
           <a:p>
-            <a:pPr indent="0" marL="0">
+            <a:pPr marL="0" indent="0">
               <a:buNone/>
             </a:pPr>
             <a:r>
@@ -4226,7 +3946,7 @@
           <a:bodyPr wrap="square" rtlCol="0" anchor="ctr"/>
           <a:lstStyle/>
           <a:p>
-            <a:pPr algn="r" indent="0" marL="0">
+            <a:pPr marL="0" indent="0" algn="r">
               <a:buNone/>
             </a:pPr>
             <a:r>
@@ -4268,6 +3988,13 @@
             <a:prstDash val="solid"/>
           </a:ln>
         </p:spPr>
+        <p:txBody>
+          <a:bodyPr/>
+          <a:lstStyle/>
+          <a:p>
+            <a:endParaRPr lang="es-ES"/>
+          </a:p>
+        </p:txBody>
       </p:sp>
       <p:sp>
         <p:nvSpPr>
@@ -4290,7 +4017,7 @@
           <a:bodyPr wrap="square" rtlCol="0" anchor="ctr"/>
           <a:lstStyle/>
           <a:p>
-            <a:pPr indent="0" marL="0">
+            <a:pPr marL="0" indent="0">
               <a:buNone/>
             </a:pPr>
             <a:r>
@@ -4357,6 +4084,13 @@
             <a:prstDash val="solid"/>
           </a:ln>
         </p:spPr>
+        <p:txBody>
+          <a:bodyPr/>
+          <a:lstStyle/>
+          <a:p>
+            <a:endParaRPr lang="es-ES"/>
+          </a:p>
+        </p:txBody>
       </p:sp>
       <p:sp>
         <p:nvSpPr>
@@ -4379,7 +4113,7 @@
           <a:bodyPr wrap="square" rtlCol="0" anchor="ctr"/>
           <a:lstStyle/>
           <a:p>
-            <a:pPr indent="0" marL="0">
+            <a:pPr marL="0" indent="0">
               <a:buNone/>
             </a:pPr>
             <a:r>
@@ -4418,7 +4152,7 @@
           <a:bodyPr wrap="square" rtlCol="0" anchor="ctr"/>
           <a:lstStyle/>
           <a:p>
-            <a:pPr algn="r" indent="0" marL="0">
+            <a:pPr marL="0" indent="0" algn="r">
               <a:buNone/>
             </a:pPr>
             <a:r>
@@ -4457,7 +4191,7 @@
           <a:bodyPr wrap="square" rtlCol="0" anchor="t"/>
           <a:lstStyle/>
           <a:p>
-            <a:pPr indent="0" marL="0">
+            <a:pPr marL="0" indent="0">
               <a:buNone/>
             </a:pPr>
             <a:r>
@@ -4499,6 +4233,13 @@
             <a:prstDash val="solid"/>
           </a:ln>
         </p:spPr>
+        <p:txBody>
+          <a:bodyPr/>
+          <a:lstStyle/>
+          <a:p>
+            <a:endParaRPr lang="es-ES"/>
+          </a:p>
+        </p:txBody>
       </p:sp>
       <p:sp>
         <p:nvSpPr>
@@ -4524,6 +4265,13 @@
             <a:prstDash val="solid"/>
           </a:ln>
         </p:spPr>
+        <p:txBody>
+          <a:bodyPr/>
+          <a:lstStyle/>
+          <a:p>
+            <a:endParaRPr lang="es-ES"/>
+          </a:p>
+        </p:txBody>
       </p:sp>
       <p:sp>
         <p:nvSpPr>
@@ -4546,7 +4294,7 @@
           <a:bodyPr wrap="square" rtlCol="0" anchor="t"/>
           <a:lstStyle/>
           <a:p>
-            <a:pPr indent="0" marL="0">
+            <a:pPr marL="0" indent="0">
               <a:buNone/>
             </a:pPr>
             <a:r>
@@ -4563,7 +4311,7 @@
             <a:endParaRPr lang="en-US" sz="1350" dirty="0"/>
           </a:p>
           <a:p>
-            <a:pPr indent="0" marL="0">
+            <a:pPr marL="0" indent="0">
               <a:buNone/>
             </a:pPr>
             <a:r>
@@ -4580,7 +4328,7 @@
             <a:endParaRPr lang="en-US" sz="1350" dirty="0"/>
           </a:p>
           <a:p>
-            <a:pPr indent="0" marL="0">
+            <a:pPr marL="0" indent="0">
               <a:buNone/>
             </a:pPr>
             <a:r>
@@ -4597,7 +4345,7 @@
             <a:endParaRPr lang="en-US" sz="1350" dirty="0"/>
           </a:p>
           <a:p>
-            <a:pPr indent="0" marL="0">
+            <a:pPr marL="0" indent="0">
               <a:buNone/>
             </a:pPr>
             <a:r>
@@ -4614,7 +4362,7 @@
             <a:endParaRPr lang="en-US" sz="1350" dirty="0"/>
           </a:p>
           <a:p>
-            <a:pPr indent="0" marL="0">
+            <a:pPr marL="0" indent="0">
               <a:buNone/>
             </a:pPr>
             <a:r>
@@ -4631,7 +4379,7 @@
             <a:endParaRPr lang="en-US" sz="1350" dirty="0"/>
           </a:p>
           <a:p>
-            <a:pPr indent="0" marL="0">
+            <a:pPr marL="0" indent="0">
               <a:buNone/>
             </a:pPr>
             <a:r>
@@ -4648,7 +4396,7 @@
             <a:endParaRPr lang="en-US" sz="1350" dirty="0"/>
           </a:p>
           <a:p>
-            <a:pPr indent="0" marL="0">
+            <a:pPr marL="0" indent="0">
               <a:buNone/>
             </a:pPr>
             <a:r>
@@ -4665,7 +4413,7 @@
             <a:endParaRPr lang="en-US" sz="1350" dirty="0"/>
           </a:p>
           <a:p>
-            <a:pPr indent="0" marL="0">
+            <a:pPr marL="0" indent="0">
               <a:buNone/>
             </a:pPr>
             <a:r>
@@ -4682,7 +4430,7 @@
             <a:endParaRPr lang="en-US" sz="1350" dirty="0"/>
           </a:p>
           <a:p>
-            <a:pPr indent="0" marL="0">
+            <a:pPr marL="0" indent="0">
               <a:buNone/>
             </a:pPr>
             <a:r>
@@ -4699,7 +4447,7 @@
             <a:endParaRPr lang="en-US" sz="1350" dirty="0"/>
           </a:p>
           <a:p>
-            <a:pPr indent="0" marL="0">
+            <a:pPr marL="0" indent="0">
               <a:buNone/>
             </a:pPr>
             <a:r>
@@ -4766,6 +4514,13 @@
             <a:prstDash val="solid"/>
           </a:ln>
         </p:spPr>
+        <p:txBody>
+          <a:bodyPr/>
+          <a:lstStyle/>
+          <a:p>
+            <a:endParaRPr lang="es-ES"/>
+          </a:p>
+        </p:txBody>
       </p:sp>
       <p:sp>
         <p:nvSpPr>
@@ -4788,7 +4543,7 @@
           <a:bodyPr wrap="square" rtlCol="0" anchor="ctr"/>
           <a:lstStyle/>
           <a:p>
-            <a:pPr indent="0" marL="0">
+            <a:pPr marL="0" indent="0">
               <a:buNone/>
             </a:pPr>
             <a:r>
@@ -4827,7 +4582,7 @@
           <a:bodyPr wrap="square" rtlCol="0" anchor="ctr"/>
           <a:lstStyle/>
           <a:p>
-            <a:pPr algn="r" indent="0" marL="0">
+            <a:pPr marL="0" indent="0" algn="r">
               <a:buNone/>
             </a:pPr>
             <a:r>
@@ -4861,15 +4616,27 @@
         </p:nvGraphicFramePr>
         <p:xfrm>
           <a:off x="548640" y="1371600"/>
-          <a:ext cx="11091672" cy="914400"/>
+          <a:ext cx="11091672" cy="3968496"/>
         </p:xfrm>
         <a:graphic>
           <a:graphicData uri="http://schemas.openxmlformats.org/drawingml/2006/table">
             <a:tbl>
               <a:tblPr/>
               <a:tblGrid>
-                <a:gridCol w="2218334"/>
-                <a:gridCol w="8873338"/>
+                <a:gridCol w="2218334">
+                  <a:extLst>
+                    <a:ext uri="{9D8B030D-6E8A-4147-A177-3AD203B41FA5}">
+                      <a16:colId xmlns:a16="http://schemas.microsoft.com/office/drawing/2014/main" val="20000"/>
+                    </a:ext>
+                  </a:extLst>
+                </a:gridCol>
+                <a:gridCol w="8873338">
+                  <a:extLst>
+                    <a:ext uri="{9D8B030D-6E8A-4147-A177-3AD203B41FA5}">
+                      <a16:colId xmlns:a16="http://schemas.microsoft.com/office/drawing/2014/main" val="20001"/>
+                    </a:ext>
+                  </a:extLst>
+                </a:gridCol>
               </a:tblGrid>
               <a:tr h="566928">
                 <a:tc>
@@ -4877,7 +4644,7 @@
                     <a:bodyPr/>
                     <a:lstStyle/>
                     <a:p>
-                      <a:pPr algn="ctr" indent="0" marL="0">
+                      <a:pPr marL="0" indent="0" algn="ctr">
                         <a:buNone/>
                       </a:pPr>
                       <a:r>
@@ -4898,7 +4665,7 @@
                       </a:endParaRPr>
                     </a:p>
                   </a:txBody>
-                  <a:tcPr marL="91440" marR="91440" marT="45720" marB="45720" anchor="ctr">
+                  <a:tcPr anchor="ctr">
                     <a:lnL w="12700" cap="flat" cmpd="sng" algn="ctr">
                       <a:solidFill>
                         <a:srgbClr val="EEEEEE"/>
@@ -4945,7 +4712,7 @@
                     <a:bodyPr/>
                     <a:lstStyle/>
                     <a:p>
-                      <a:pPr algn="ctr" indent="0" marL="0">
+                      <a:pPr marL="0" indent="0" algn="ctr">
                         <a:buNone/>
                       </a:pPr>
                       <a:r>
@@ -4966,7 +4733,7 @@
                       </a:endParaRPr>
                     </a:p>
                   </a:txBody>
-                  <a:tcPr marL="91440" marR="91440" marT="45720" marB="45720" anchor="ctr">
+                  <a:tcPr anchor="ctr">
                     <a:lnL w="12700" cap="flat" cmpd="sng" algn="ctr">
                       <a:solidFill>
                         <a:srgbClr val="EEEEEE"/>
@@ -5008,6 +4775,11 @@
                     </a:solidFill>
                   </a:tcPr>
                 </a:tc>
+                <a:extLst>
+                  <a:ext uri="{0D108BD9-81ED-4DB2-BD59-A6C34878D82A}">
+                    <a16:rowId xmlns:a16="http://schemas.microsoft.com/office/drawing/2014/main" val="10000"/>
+                  </a:ext>
+                </a:extLst>
               </a:tr>
               <a:tr h="566928">
                 <a:tc>
@@ -5015,7 +4787,7 @@
                     <a:bodyPr/>
                     <a:lstStyle/>
                     <a:p>
-                      <a:pPr indent="0" marL="0">
+                      <a:pPr marL="0" indent="0">
                         <a:buNone/>
                       </a:pPr>
                       <a:r>
@@ -5036,7 +4808,7 @@
                       </a:endParaRPr>
                     </a:p>
                   </a:txBody>
-                  <a:tcPr marL="91440" marR="91440" marT="45720" marB="45720" anchor="ctr">
+                  <a:tcPr anchor="ctr">
                     <a:lnL w="12700" cap="flat" cmpd="sng" algn="ctr">
                       <a:solidFill>
                         <a:srgbClr val="EEEEEE"/>
@@ -5083,7 +4855,7 @@
                     <a:bodyPr/>
                     <a:lstStyle/>
                     <a:p>
-                      <a:pPr indent="0" marL="0">
+                      <a:pPr marL="0" indent="0">
                         <a:buNone/>
                       </a:pPr>
                       <a:r>
@@ -5104,7 +4876,7 @@
                       </a:endParaRPr>
                     </a:p>
                   </a:txBody>
-                  <a:tcPr marL="91440" marR="91440" marT="45720" marB="45720" anchor="ctr">
+                  <a:tcPr anchor="ctr">
                     <a:lnL w="12700" cap="flat" cmpd="sng" algn="ctr">
                       <a:solidFill>
                         <a:srgbClr val="EEEEEE"/>
@@ -5146,6 +4918,11 @@
                     </a:solidFill>
                   </a:tcPr>
                 </a:tc>
+                <a:extLst>
+                  <a:ext uri="{0D108BD9-81ED-4DB2-BD59-A6C34878D82A}">
+                    <a16:rowId xmlns:a16="http://schemas.microsoft.com/office/drawing/2014/main" val="10001"/>
+                  </a:ext>
+                </a:extLst>
               </a:tr>
               <a:tr h="566928">
                 <a:tc>
@@ -5153,7 +4930,7 @@
                     <a:bodyPr/>
                     <a:lstStyle/>
                     <a:p>
-                      <a:pPr indent="0" marL="0">
+                      <a:pPr marL="0" indent="0">
                         <a:buNone/>
                       </a:pPr>
                       <a:r>
@@ -5174,7 +4951,7 @@
                       </a:endParaRPr>
                     </a:p>
                   </a:txBody>
-                  <a:tcPr marL="91440" marR="91440" marT="45720" marB="45720" anchor="ctr">
+                  <a:tcPr anchor="ctr">
                     <a:lnL w="12700" cap="flat" cmpd="sng" algn="ctr">
                       <a:solidFill>
                         <a:srgbClr val="EEEEEE"/>
@@ -5221,7 +4998,7 @@
                     <a:bodyPr/>
                     <a:lstStyle/>
                     <a:p>
-                      <a:pPr indent="0" marL="0">
+                      <a:pPr marL="0" indent="0">
                         <a:buNone/>
                       </a:pPr>
                       <a:r>
@@ -5242,7 +5019,7 @@
                       </a:endParaRPr>
                     </a:p>
                   </a:txBody>
-                  <a:tcPr marL="91440" marR="91440" marT="45720" marB="45720" anchor="ctr">
+                  <a:tcPr anchor="ctr">
                     <a:lnL w="12700" cap="flat" cmpd="sng" algn="ctr">
                       <a:solidFill>
                         <a:srgbClr val="EEEEEE"/>
@@ -5284,6 +5061,11 @@
                     </a:solidFill>
                   </a:tcPr>
                 </a:tc>
+                <a:extLst>
+                  <a:ext uri="{0D108BD9-81ED-4DB2-BD59-A6C34878D82A}">
+                    <a16:rowId xmlns:a16="http://schemas.microsoft.com/office/drawing/2014/main" val="10002"/>
+                  </a:ext>
+                </a:extLst>
               </a:tr>
               <a:tr h="566928">
                 <a:tc>
@@ -5291,7 +5073,7 @@
                     <a:bodyPr/>
                     <a:lstStyle/>
                     <a:p>
-                      <a:pPr indent="0" marL="0">
+                      <a:pPr marL="0" indent="0">
                         <a:buNone/>
                       </a:pPr>
                       <a:r>
@@ -5312,7 +5094,7 @@
                       </a:endParaRPr>
                     </a:p>
                   </a:txBody>
-                  <a:tcPr marL="91440" marR="91440" marT="45720" marB="45720" anchor="ctr">
+                  <a:tcPr anchor="ctr">
                     <a:lnL w="12700" cap="flat" cmpd="sng" algn="ctr">
                       <a:solidFill>
                         <a:srgbClr val="EEEEEE"/>
@@ -5359,7 +5141,7 @@
                     <a:bodyPr/>
                     <a:lstStyle/>
                     <a:p>
-                      <a:pPr indent="0" marL="0">
+                      <a:pPr marL="0" indent="0">
                         <a:buNone/>
                       </a:pPr>
                       <a:r>
@@ -5380,7 +5162,7 @@
                       </a:endParaRPr>
                     </a:p>
                   </a:txBody>
-                  <a:tcPr marL="91440" marR="91440" marT="45720" marB="45720" anchor="ctr">
+                  <a:tcPr anchor="ctr">
                     <a:lnL w="12700" cap="flat" cmpd="sng" algn="ctr">
                       <a:solidFill>
                         <a:srgbClr val="EEEEEE"/>
@@ -5422,6 +5204,11 @@
                     </a:solidFill>
                   </a:tcPr>
                 </a:tc>
+                <a:extLst>
+                  <a:ext uri="{0D108BD9-81ED-4DB2-BD59-A6C34878D82A}">
+                    <a16:rowId xmlns:a16="http://schemas.microsoft.com/office/drawing/2014/main" val="10003"/>
+                  </a:ext>
+                </a:extLst>
               </a:tr>
               <a:tr h="566928">
                 <a:tc>
@@ -5429,7 +5216,7 @@
                     <a:bodyPr/>
                     <a:lstStyle/>
                     <a:p>
-                      <a:pPr indent="0" marL="0">
+                      <a:pPr marL="0" indent="0">
                         <a:buNone/>
                       </a:pPr>
                       <a:r>
@@ -5450,7 +5237,7 @@
                       </a:endParaRPr>
                     </a:p>
                   </a:txBody>
-                  <a:tcPr marL="91440" marR="91440" marT="45720" marB="45720" anchor="ctr">
+                  <a:tcPr anchor="ctr">
                     <a:lnL w="12700" cap="flat" cmpd="sng" algn="ctr">
                       <a:solidFill>
                         <a:srgbClr val="EEEEEE"/>
@@ -5497,7 +5284,7 @@
                     <a:bodyPr/>
                     <a:lstStyle/>
                     <a:p>
-                      <a:pPr indent="0" marL="0">
+                      <a:pPr marL="0" indent="0">
                         <a:buNone/>
                       </a:pPr>
                       <a:r>
@@ -5518,7 +5305,7 @@
                       </a:endParaRPr>
                     </a:p>
                   </a:txBody>
-                  <a:tcPr marL="91440" marR="91440" marT="45720" marB="45720" anchor="ctr">
+                  <a:tcPr anchor="ctr">
                     <a:lnL w="12700" cap="flat" cmpd="sng" algn="ctr">
                       <a:solidFill>
                         <a:srgbClr val="EEEEEE"/>
@@ -5560,6 +5347,11 @@
                     </a:solidFill>
                   </a:tcPr>
                 </a:tc>
+                <a:extLst>
+                  <a:ext uri="{0D108BD9-81ED-4DB2-BD59-A6C34878D82A}">
+                    <a16:rowId xmlns:a16="http://schemas.microsoft.com/office/drawing/2014/main" val="10004"/>
+                  </a:ext>
+                </a:extLst>
               </a:tr>
               <a:tr h="566928">
                 <a:tc>
@@ -5567,7 +5359,7 @@
                     <a:bodyPr/>
                     <a:lstStyle/>
                     <a:p>
-                      <a:pPr indent="0" marL="0">
+                      <a:pPr marL="0" indent="0">
                         <a:buNone/>
                       </a:pPr>
                       <a:r>
@@ -5588,7 +5380,7 @@
                       </a:endParaRPr>
                     </a:p>
                   </a:txBody>
-                  <a:tcPr marL="91440" marR="91440" marT="45720" marB="45720" anchor="ctr">
+                  <a:tcPr anchor="ctr">
                     <a:lnL w="12700" cap="flat" cmpd="sng" algn="ctr">
                       <a:solidFill>
                         <a:srgbClr val="EEEEEE"/>
@@ -5635,7 +5427,7 @@
                     <a:bodyPr/>
                     <a:lstStyle/>
                     <a:p>
-                      <a:pPr indent="0" marL="0">
+                      <a:pPr marL="0" indent="0">
                         <a:buNone/>
                       </a:pPr>
                       <a:r>
@@ -5656,7 +5448,7 @@
                       </a:endParaRPr>
                     </a:p>
                   </a:txBody>
-                  <a:tcPr marL="91440" marR="91440" marT="45720" marB="45720" anchor="ctr">
+                  <a:tcPr anchor="ctr">
                     <a:lnL w="12700" cap="flat" cmpd="sng" algn="ctr">
                       <a:solidFill>
                         <a:srgbClr val="EEEEEE"/>
@@ -5698,6 +5490,11 @@
                     </a:solidFill>
                   </a:tcPr>
                 </a:tc>
+                <a:extLst>
+                  <a:ext uri="{0D108BD9-81ED-4DB2-BD59-A6C34878D82A}">
+                    <a16:rowId xmlns:a16="http://schemas.microsoft.com/office/drawing/2014/main" val="10005"/>
+                  </a:ext>
+                </a:extLst>
               </a:tr>
               <a:tr h="566928">
                 <a:tc>
@@ -5705,7 +5502,7 @@
                     <a:bodyPr/>
                     <a:lstStyle/>
                     <a:p>
-                      <a:pPr indent="0" marL="0">
+                      <a:pPr marL="0" indent="0">
                         <a:buNone/>
                       </a:pPr>
                       <a:r>
@@ -5726,7 +5523,7 @@
                       </a:endParaRPr>
                     </a:p>
                   </a:txBody>
-                  <a:tcPr marL="91440" marR="91440" marT="45720" marB="45720" anchor="ctr">
+                  <a:tcPr anchor="ctr">
                     <a:lnL w="12700" cap="flat" cmpd="sng" algn="ctr">
                       <a:solidFill>
                         <a:srgbClr val="EEEEEE"/>
@@ -5773,7 +5570,7 @@
                     <a:bodyPr/>
                     <a:lstStyle/>
                     <a:p>
-                      <a:pPr indent="0" marL="0">
+                      <a:pPr marL="0" indent="0">
                         <a:buNone/>
                       </a:pPr>
                       <a:r>
@@ -5794,7 +5591,7 @@
                       </a:endParaRPr>
                     </a:p>
                   </a:txBody>
-                  <a:tcPr marL="91440" marR="91440" marT="45720" marB="45720" anchor="ctr">
+                  <a:tcPr anchor="ctr">
                     <a:lnL w="12700" cap="flat" cmpd="sng" algn="ctr">
                       <a:solidFill>
                         <a:srgbClr val="EEEEEE"/>
@@ -5836,6 +5633,11 @@
                     </a:solidFill>
                   </a:tcPr>
                 </a:tc>
+                <a:extLst>
+                  <a:ext uri="{0D108BD9-81ED-4DB2-BD59-A6C34878D82A}">
+                    <a16:rowId xmlns:a16="http://schemas.microsoft.com/office/drawing/2014/main" val="10006"/>
+                  </a:ext>
+                </a:extLst>
               </a:tr>
             </a:tbl>
           </a:graphicData>
@@ -5890,6 +5692,13 @@
             <a:prstDash val="solid"/>
           </a:ln>
         </p:spPr>
+        <p:txBody>
+          <a:bodyPr/>
+          <a:lstStyle/>
+          <a:p>
+            <a:endParaRPr lang="es-ES"/>
+          </a:p>
+        </p:txBody>
       </p:sp>
       <p:sp>
         <p:nvSpPr>
@@ -5912,7 +5721,7 @@
           <a:bodyPr wrap="square" rtlCol="0" anchor="ctr"/>
           <a:lstStyle/>
           <a:p>
-            <a:pPr indent="0" marL="0">
+            <a:pPr marL="0" indent="0">
               <a:buNone/>
             </a:pPr>
             <a:r>
@@ -5951,7 +5760,7 @@
           <a:bodyPr wrap="square" rtlCol="0" anchor="ctr"/>
           <a:lstStyle/>
           <a:p>
-            <a:pPr algn="r" indent="0" marL="0">
+            <a:pPr marL="0" indent="0" algn="r">
               <a:buNone/>
             </a:pPr>
             <a:r>
@@ -5993,6 +5802,13 @@
             <a:prstDash val="solid"/>
           </a:ln>
         </p:spPr>
+        <p:txBody>
+          <a:bodyPr/>
+          <a:lstStyle/>
+          <a:p>
+            <a:endParaRPr lang="es-ES"/>
+          </a:p>
+        </p:txBody>
       </p:sp>
       <p:sp>
         <p:nvSpPr>
@@ -6015,7 +5831,7 @@
           <a:bodyPr wrap="square" rtlCol="0" anchor="ctr"/>
           <a:lstStyle/>
           <a:p>
-            <a:pPr indent="0" marL="0">
+            <a:pPr marL="0" indent="0">
               <a:buNone/>
             </a:pPr>
             <a:r>
@@ -6082,6 +5898,13 @@
             <a:prstDash val="solid"/>
           </a:ln>
         </p:spPr>
+        <p:txBody>
+          <a:bodyPr/>
+          <a:lstStyle/>
+          <a:p>
+            <a:endParaRPr lang="es-ES"/>
+          </a:p>
+        </p:txBody>
       </p:sp>
       <p:sp>
         <p:nvSpPr>
@@ -6104,7 +5927,7 @@
           <a:bodyPr wrap="square" rtlCol="0" anchor="ctr"/>
           <a:lstStyle/>
           <a:p>
-            <a:pPr indent="0" marL="0">
+            <a:pPr marL="0" indent="0">
               <a:buNone/>
             </a:pPr>
             <a:r>
@@ -6143,7 +5966,7 @@
           <a:bodyPr wrap="square" rtlCol="0" anchor="ctr"/>
           <a:lstStyle/>
           <a:p>
-            <a:pPr algn="r" indent="0" marL="0">
+            <a:pPr marL="0" indent="0" algn="r">
               <a:buNone/>
             </a:pPr>
             <a:r>
@@ -6182,7 +6005,7 @@
           <a:bodyPr wrap="square" rtlCol="0" anchor="t"/>
           <a:lstStyle/>
           <a:p>
-            <a:pPr indent="0" marL="0">
+            <a:pPr marL="0" indent="0">
               <a:buNone/>
             </a:pPr>
             <a:r>
@@ -6202,14 +6025,14 @@
       </p:sp>
       <p:pic>
         <p:nvPicPr>
-          <p:cNvPr id="6" name="Image 0" descr="C:/Users/Aitor/docxgen/img/psp-t2-exception-routing.png">    </p:cNvPr>
+          <p:cNvPr id="6" name="Image 0" descr="C:/Users/Aitor/docxgen/img/psp-t2-exception-routing.png"/>
           <p:cNvPicPr>
             <a:picLocks noChangeAspect="1"/>
           </p:cNvPicPr>
           <p:nvPr/>
         </p:nvPicPr>
         <p:blipFill>
-          <a:blip r:embed="rId1"/>
+          <a:blip r:embed="rId3"/>
           <a:stretch>
             <a:fillRect/>
           </a:stretch>
@@ -6273,6 +6096,13 @@
             <a:prstDash val="solid"/>
           </a:ln>
         </p:spPr>
+        <p:txBody>
+          <a:bodyPr/>
+          <a:lstStyle/>
+          <a:p>
+            <a:endParaRPr lang="es-ES"/>
+          </a:p>
+        </p:txBody>
       </p:sp>
       <p:sp>
         <p:nvSpPr>
@@ -6295,7 +6125,7 @@
           <a:bodyPr wrap="square" rtlCol="0" anchor="ctr"/>
           <a:lstStyle/>
           <a:p>
-            <a:pPr indent="0" marL="0">
+            <a:pPr marL="0" indent="0">
               <a:buNone/>
             </a:pPr>
             <a:r>
@@ -6334,7 +6164,7 @@
           <a:bodyPr wrap="square" rtlCol="0" anchor="ctr"/>
           <a:lstStyle/>
           <a:p>
-            <a:pPr algn="r" indent="0" marL="0">
+            <a:pPr marL="0" indent="0" algn="r">
               <a:buNone/>
             </a:pPr>
             <a:r>
@@ -6373,7 +6203,7 @@
           <a:bodyPr wrap="square" rtlCol="0" anchor="t"/>
           <a:lstStyle/>
           <a:p>
-            <a:pPr indent="0" marL="0">
+            <a:pPr marL="0" indent="0">
               <a:buNone/>
             </a:pPr>
             <a:r>
@@ -6415,6 +6245,13 @@
             <a:prstDash val="solid"/>
           </a:ln>
         </p:spPr>
+        <p:txBody>
+          <a:bodyPr/>
+          <a:lstStyle/>
+          <a:p>
+            <a:endParaRPr lang="es-ES"/>
+          </a:p>
+        </p:txBody>
       </p:sp>
       <p:sp>
         <p:nvSpPr>
@@ -6440,6 +6277,13 @@
             <a:prstDash val="solid"/>
           </a:ln>
         </p:spPr>
+        <p:txBody>
+          <a:bodyPr/>
+          <a:lstStyle/>
+          <a:p>
+            <a:endParaRPr lang="es-ES"/>
+          </a:p>
+        </p:txBody>
       </p:sp>
       <p:sp>
         <p:nvSpPr>
@@ -6462,7 +6306,7 @@
           <a:bodyPr wrap="square" rtlCol="0" anchor="t"/>
           <a:lstStyle/>
           <a:p>
-            <a:pPr indent="0" marL="0">
+            <a:pPr marL="0" indent="0">
               <a:buNone/>
             </a:pPr>
             <a:r>
@@ -6479,7 +6323,7 @@
             <a:endParaRPr lang="en-US" sz="1250" dirty="0"/>
           </a:p>
           <a:p>
-            <a:pPr indent="0" marL="0">
+            <a:pPr marL="0" indent="0">
               <a:buNone/>
             </a:pPr>
             <a:r>
@@ -6496,7 +6340,7 @@
             <a:endParaRPr lang="en-US" sz="1250" dirty="0"/>
           </a:p>
           <a:p>
-            <a:pPr indent="0" marL="0">
+            <a:pPr marL="0" indent="0">
               <a:buNone/>
             </a:pPr>
             <a:r>
@@ -6513,13 +6357,13 @@
             <a:endParaRPr lang="en-US" sz="1250" dirty="0"/>
           </a:p>
           <a:p>
-            <a:pPr indent="0" marL="0">
+            <a:pPr marL="0" indent="0">
               <a:buNone/>
             </a:pPr>
             <a:endParaRPr lang="en-US" sz="1250" dirty="0"/>
           </a:p>
           <a:p>
-            <a:pPr indent="0" marL="0">
+            <a:pPr marL="0" indent="0">
               <a:buNone/>
             </a:pPr>
             <a:r>
@@ -6536,7 +6380,7 @@
             <a:endParaRPr lang="en-US" sz="1250" dirty="0"/>
           </a:p>
           <a:p>
-            <a:pPr indent="0" marL="0">
+            <a:pPr marL="0" indent="0">
               <a:buNone/>
             </a:pPr>
             <a:r>
@@ -6553,7 +6397,7 @@
             <a:endParaRPr lang="en-US" sz="1250" dirty="0"/>
           </a:p>
           <a:p>
-            <a:pPr indent="0" marL="0">
+            <a:pPr marL="0" indent="0">
               <a:buNone/>
             </a:pPr>
             <a:r>
@@ -6570,13 +6414,13 @@
             <a:endParaRPr lang="en-US" sz="1250" dirty="0"/>
           </a:p>
           <a:p>
-            <a:pPr indent="0" marL="0">
+            <a:pPr marL="0" indent="0">
               <a:buNone/>
             </a:pPr>
             <a:endParaRPr lang="en-US" sz="1250" dirty="0"/>
           </a:p>
           <a:p>
-            <a:pPr indent="0" marL="0">
+            <a:pPr marL="0" indent="0">
               <a:buNone/>
             </a:pPr>
             <a:r>
@@ -6593,7 +6437,7 @@
             <a:endParaRPr lang="en-US" sz="1250" dirty="0"/>
           </a:p>
           <a:p>
-            <a:pPr indent="0" marL="0">
+            <a:pPr marL="0" indent="0">
               <a:buNone/>
             </a:pPr>
             <a:r>
@@ -6610,7 +6454,7 @@
             <a:endParaRPr lang="en-US" sz="1250" dirty="0"/>
           </a:p>
           <a:p>
-            <a:pPr indent="0" marL="0">
+            <a:pPr marL="0" indent="0">
               <a:buNone/>
             </a:pPr>
             <a:r>
@@ -6627,7 +6471,7 @@
             <a:endParaRPr lang="en-US" sz="1250" dirty="0"/>
           </a:p>
           <a:p>
-            <a:pPr indent="0" marL="0">
+            <a:pPr marL="0" indent="0">
               <a:buNone/>
             </a:pPr>
             <a:r>
@@ -6644,7 +6488,7 @@
             <a:endParaRPr lang="en-US" sz="1250" dirty="0"/>
           </a:p>
           <a:p>
-            <a:pPr indent="0" marL="0">
+            <a:pPr marL="0" indent="0">
               <a:buNone/>
             </a:pPr>
             <a:r>
@@ -6711,6 +6555,13 @@
             <a:prstDash val="solid"/>
           </a:ln>
         </p:spPr>
+        <p:txBody>
+          <a:bodyPr/>
+          <a:lstStyle/>
+          <a:p>
+            <a:endParaRPr lang="es-ES"/>
+          </a:p>
+        </p:txBody>
       </p:sp>
       <p:sp>
         <p:nvSpPr>
@@ -6733,7 +6584,7 @@
           <a:bodyPr wrap="square" rtlCol="0" anchor="ctr"/>
           <a:lstStyle/>
           <a:p>
-            <a:pPr indent="0" marL="0">
+            <a:pPr marL="0" indent="0">
               <a:buNone/>
             </a:pPr>
             <a:r>
@@ -6772,7 +6623,7 @@
           <a:bodyPr wrap="square" rtlCol="0" anchor="ctr"/>
           <a:lstStyle/>
           <a:p>
-            <a:pPr algn="r" indent="0" marL="0">
+            <a:pPr marL="0" indent="0" algn="r">
               <a:buNone/>
             </a:pPr>
             <a:r>
@@ -6814,6 +6665,13 @@
             <a:prstDash val="solid"/>
           </a:ln>
         </p:spPr>
+        <p:txBody>
+          <a:bodyPr/>
+          <a:lstStyle/>
+          <a:p>
+            <a:endParaRPr lang="es-ES"/>
+          </a:p>
+        </p:txBody>
       </p:sp>
       <p:sp>
         <p:nvSpPr>
@@ -6836,7 +6694,7 @@
           <a:bodyPr wrap="square" rtlCol="0" anchor="ctr"/>
           <a:lstStyle/>
           <a:p>
-            <a:pPr indent="0" marL="0">
+            <a:pPr marL="0" indent="0">
               <a:buNone/>
             </a:pPr>
             <a:r>
@@ -6903,6 +6761,13 @@
             <a:prstDash val="solid"/>
           </a:ln>
         </p:spPr>
+        <p:txBody>
+          <a:bodyPr/>
+          <a:lstStyle/>
+          <a:p>
+            <a:endParaRPr lang="es-ES"/>
+          </a:p>
+        </p:txBody>
       </p:sp>
       <p:sp>
         <p:nvSpPr>
@@ -6925,7 +6790,7 @@
           <a:bodyPr wrap="square" rtlCol="0" anchor="ctr"/>
           <a:lstStyle/>
           <a:p>
-            <a:pPr indent="0" marL="0">
+            <a:pPr marL="0" indent="0">
               <a:buNone/>
             </a:pPr>
             <a:r>
@@ -6964,7 +6829,7 @@
           <a:bodyPr wrap="square" rtlCol="0" anchor="ctr"/>
           <a:lstStyle/>
           <a:p>
-            <a:pPr algn="r" indent="0" marL="0">
+            <a:pPr marL="0" indent="0" algn="r">
               <a:buNone/>
             </a:pPr>
             <a:r>
@@ -7003,7 +6868,7 @@
           <a:bodyPr wrap="square" rtlCol="0" anchor="t"/>
           <a:lstStyle/>
           <a:p>
-            <a:pPr indent="0" marL="0">
+            <a:pPr marL="0" indent="0">
               <a:buNone/>
             </a:pPr>
             <a:r>
@@ -7045,6 +6910,13 @@
             <a:prstDash val="solid"/>
           </a:ln>
         </p:spPr>
+        <p:txBody>
+          <a:bodyPr/>
+          <a:lstStyle/>
+          <a:p>
+            <a:endParaRPr lang="es-ES"/>
+          </a:p>
+        </p:txBody>
       </p:sp>
       <p:sp>
         <p:nvSpPr>
@@ -7070,6 +6942,13 @@
             <a:prstDash val="solid"/>
           </a:ln>
         </p:spPr>
+        <p:txBody>
+          <a:bodyPr/>
+          <a:lstStyle/>
+          <a:p>
+            <a:endParaRPr lang="es-ES"/>
+          </a:p>
+        </p:txBody>
       </p:sp>
       <p:sp>
         <p:nvSpPr>
@@ -7092,7 +6971,7 @@
           <a:bodyPr wrap="square" rtlCol="0" anchor="t"/>
           <a:lstStyle/>
           <a:p>
-            <a:pPr indent="0" marL="0">
+            <a:pPr marL="0" indent="0">
               <a:buNone/>
             </a:pPr>
             <a:r>
@@ -7109,7 +6988,7 @@
             <a:endParaRPr lang="en-US" sz="1250" dirty="0"/>
           </a:p>
           <a:p>
-            <a:pPr indent="0" marL="0">
+            <a:pPr marL="0" indent="0">
               <a:buNone/>
             </a:pPr>
             <a:r>
@@ -7126,7 +7005,7 @@
             <a:endParaRPr lang="en-US" sz="1250" dirty="0"/>
           </a:p>
           <a:p>
-            <a:pPr indent="0" marL="0">
+            <a:pPr marL="0" indent="0">
               <a:buNone/>
             </a:pPr>
             <a:r>
@@ -7143,13 +7022,13 @@
             <a:endParaRPr lang="en-US" sz="1250" dirty="0"/>
           </a:p>
           <a:p>
-            <a:pPr indent="0" marL="0">
+            <a:pPr marL="0" indent="0">
               <a:buNone/>
             </a:pPr>
             <a:endParaRPr lang="en-US" sz="1250" dirty="0"/>
           </a:p>
           <a:p>
-            <a:pPr indent="0" marL="0">
+            <a:pPr marL="0" indent="0">
               <a:buNone/>
             </a:pPr>
             <a:r>
@@ -7166,7 +7045,7 @@
             <a:endParaRPr lang="en-US" sz="1250" dirty="0"/>
           </a:p>
           <a:p>
-            <a:pPr indent="0" marL="0">
+            <a:pPr marL="0" indent="0">
               <a:buNone/>
             </a:pPr>
             <a:r>
@@ -7183,7 +7062,7 @@
             <a:endParaRPr lang="en-US" sz="1250" dirty="0"/>
           </a:p>
           <a:p>
-            <a:pPr indent="0" marL="0">
+            <a:pPr marL="0" indent="0">
               <a:buNone/>
             </a:pPr>
             <a:r>
@@ -7200,7 +7079,7 @@
             <a:endParaRPr lang="en-US" sz="1250" dirty="0"/>
           </a:p>
           <a:p>
-            <a:pPr indent="0" marL="0">
+            <a:pPr marL="0" indent="0">
               <a:buNone/>
             </a:pPr>
             <a:r>
@@ -7217,13 +7096,13 @@
             <a:endParaRPr lang="en-US" sz="1250" dirty="0"/>
           </a:p>
           <a:p>
-            <a:pPr indent="0" marL="0">
+            <a:pPr marL="0" indent="0">
               <a:buNone/>
             </a:pPr>
             <a:endParaRPr lang="en-US" sz="1250" dirty="0"/>
           </a:p>
           <a:p>
-            <a:pPr indent="0" marL="0">
+            <a:pPr marL="0" indent="0">
               <a:buNone/>
             </a:pPr>
             <a:r>
@@ -7240,7 +7119,7 @@
             <a:endParaRPr lang="en-US" sz="1250" dirty="0"/>
           </a:p>
           <a:p>
-            <a:pPr indent="0" marL="0">
+            <a:pPr marL="0" indent="0">
               <a:buNone/>
             </a:pPr>
             <a:r>
@@ -7257,7 +7136,7 @@
             <a:endParaRPr lang="en-US" sz="1250" dirty="0"/>
           </a:p>
           <a:p>
-            <a:pPr indent="0" marL="0">
+            <a:pPr marL="0" indent="0">
               <a:buNone/>
             </a:pPr>
             <a:r>
@@ -7274,7 +7153,7 @@
             <a:endParaRPr lang="en-US" sz="1250" dirty="0"/>
           </a:p>
           <a:p>
-            <a:pPr indent="0" marL="0">
+            <a:pPr marL="0" indent="0">
               <a:buNone/>
             </a:pPr>
             <a:r>
@@ -7341,6 +7220,13 @@
             <a:prstDash val="solid"/>
           </a:ln>
         </p:spPr>
+        <p:txBody>
+          <a:bodyPr/>
+          <a:lstStyle/>
+          <a:p>
+            <a:endParaRPr lang="es-ES"/>
+          </a:p>
+        </p:txBody>
       </p:sp>
       <p:sp>
         <p:nvSpPr>
@@ -7363,7 +7249,7 @@
           <a:bodyPr wrap="square" rtlCol="0" anchor="ctr"/>
           <a:lstStyle/>
           <a:p>
-            <a:pPr indent="0" marL="0">
+            <a:pPr marL="0" indent="0">
               <a:buNone/>
             </a:pPr>
             <a:r>
@@ -7402,7 +7288,7 @@
           <a:bodyPr wrap="square" rtlCol="0" anchor="ctr"/>
           <a:lstStyle/>
           <a:p>
-            <a:pPr algn="r" indent="0" marL="0">
+            <a:pPr marL="0" indent="0" algn="r">
               <a:buNone/>
             </a:pPr>
             <a:r>
@@ -7444,6 +7330,13 @@
             <a:prstDash val="solid"/>
           </a:ln>
         </p:spPr>
+        <p:txBody>
+          <a:bodyPr/>
+          <a:lstStyle/>
+          <a:p>
+            <a:endParaRPr lang="es-ES"/>
+          </a:p>
+        </p:txBody>
       </p:sp>
       <p:sp>
         <p:nvSpPr>
@@ -7466,7 +7359,7 @@
           <a:bodyPr wrap="square" rtlCol="0" anchor="ctr"/>
           <a:lstStyle/>
           <a:p>
-            <a:pPr indent="0" marL="0">
+            <a:pPr marL="0" indent="0">
               <a:buNone/>
             </a:pPr>
             <a:r>
@@ -7533,6 +7426,13 @@
             <a:prstDash val="solid"/>
           </a:ln>
         </p:spPr>
+        <p:txBody>
+          <a:bodyPr/>
+          <a:lstStyle/>
+          <a:p>
+            <a:endParaRPr lang="es-ES"/>
+          </a:p>
+        </p:txBody>
       </p:sp>
       <p:sp>
         <p:nvSpPr>
@@ -7555,7 +7455,7 @@
           <a:bodyPr wrap="square" rtlCol="0" anchor="ctr"/>
           <a:lstStyle/>
           <a:p>
-            <a:pPr indent="0" marL="0">
+            <a:pPr marL="0" indent="0">
               <a:buNone/>
             </a:pPr>
             <a:r>
@@ -7594,7 +7494,7 @@
           <a:bodyPr wrap="square" rtlCol="0" anchor="ctr"/>
           <a:lstStyle/>
           <a:p>
-            <a:pPr algn="r" indent="0" marL="0">
+            <a:pPr marL="0" indent="0" algn="r">
               <a:buNone/>
             </a:pPr>
             <a:r>
@@ -7636,6 +7536,13 @@
             <a:prstDash val="solid"/>
           </a:ln>
         </p:spPr>
+        <p:txBody>
+          <a:bodyPr/>
+          <a:lstStyle/>
+          <a:p>
+            <a:endParaRPr lang="es-ES"/>
+          </a:p>
+        </p:txBody>
       </p:sp>
       <p:sp>
         <p:nvSpPr>
@@ -7658,7 +7565,7 @@
           <a:bodyPr wrap="square" rtlCol="0" anchor="ctr"/>
           <a:lstStyle/>
           <a:p>
-            <a:pPr indent="0" marL="0">
+            <a:pPr marL="0" indent="0">
               <a:buNone/>
             </a:pPr>
             <a:r>
@@ -7725,6 +7632,13 @@
             <a:prstDash val="solid"/>
           </a:ln>
         </p:spPr>
+        <p:txBody>
+          <a:bodyPr/>
+          <a:lstStyle/>
+          <a:p>
+            <a:endParaRPr lang="es-ES"/>
+          </a:p>
+        </p:txBody>
       </p:sp>
       <p:sp>
         <p:nvSpPr>
@@ -7747,7 +7661,7 @@
           <a:bodyPr wrap="square" rtlCol="0" anchor="ctr"/>
           <a:lstStyle/>
           <a:p>
-            <a:pPr indent="0" marL="0">
+            <a:pPr marL="0" indent="0">
               <a:buNone/>
             </a:pPr>
             <a:r>
@@ -7786,7 +7700,7 @@
           <a:bodyPr wrap="square" rtlCol="0" anchor="ctr"/>
           <a:lstStyle/>
           <a:p>
-            <a:pPr algn="r" indent="0" marL="0">
+            <a:pPr marL="0" indent="0" algn="r">
               <a:buNone/>
             </a:pPr>
             <a:r>
@@ -7825,7 +7739,7 @@
           <a:bodyPr wrap="square" rtlCol="0" anchor="t"/>
           <a:lstStyle/>
           <a:p>
-            <a:pPr indent="0" marL="0">
+            <a:pPr marL="0" indent="0">
               <a:buNone/>
             </a:pPr>
             <a:r>
@@ -7867,6 +7781,13 @@
             <a:prstDash val="solid"/>
           </a:ln>
         </p:spPr>
+        <p:txBody>
+          <a:bodyPr/>
+          <a:lstStyle/>
+          <a:p>
+            <a:endParaRPr lang="es-ES"/>
+          </a:p>
+        </p:txBody>
       </p:sp>
       <p:sp>
         <p:nvSpPr>
@@ -7892,6 +7813,13 @@
             <a:prstDash val="solid"/>
           </a:ln>
         </p:spPr>
+        <p:txBody>
+          <a:bodyPr/>
+          <a:lstStyle/>
+          <a:p>
+            <a:endParaRPr lang="es-ES"/>
+          </a:p>
+        </p:txBody>
       </p:sp>
       <p:sp>
         <p:nvSpPr>
@@ -7914,7 +7842,7 @@
           <a:bodyPr wrap="square" rtlCol="0" anchor="t"/>
           <a:lstStyle/>
           <a:p>
-            <a:pPr indent="0" marL="0">
+            <a:pPr marL="0" indent="0">
               <a:buNone/>
             </a:pPr>
             <a:r>
@@ -7931,7 +7859,7 @@
             <a:endParaRPr lang="en-US" sz="1300" dirty="0"/>
           </a:p>
           <a:p>
-            <a:pPr indent="0" marL="0">
+            <a:pPr marL="0" indent="0">
               <a:buNone/>
             </a:pPr>
             <a:r>
@@ -7948,7 +7876,7 @@
             <a:endParaRPr lang="en-US" sz="1300" dirty="0"/>
           </a:p>
           <a:p>
-            <a:pPr indent="0" marL="0">
+            <a:pPr marL="0" indent="0">
               <a:buNone/>
             </a:pPr>
             <a:r>
@@ -7965,13 +7893,13 @@
             <a:endParaRPr lang="en-US" sz="1300" dirty="0"/>
           </a:p>
           <a:p>
-            <a:pPr indent="0" marL="0">
+            <a:pPr marL="0" indent="0">
               <a:buNone/>
             </a:pPr>
             <a:endParaRPr lang="en-US" sz="1300" dirty="0"/>
           </a:p>
           <a:p>
-            <a:pPr indent="0" marL="0">
+            <a:pPr marL="0" indent="0">
               <a:buNone/>
             </a:pPr>
             <a:r>
@@ -7988,7 +7916,7 @@
             <a:endParaRPr lang="en-US" sz="1300" dirty="0"/>
           </a:p>
           <a:p>
-            <a:pPr indent="0" marL="0">
+            <a:pPr marL="0" indent="0">
               <a:buNone/>
             </a:pPr>
             <a:r>
@@ -8005,7 +7933,7 @@
             <a:endParaRPr lang="en-US" sz="1300" dirty="0"/>
           </a:p>
           <a:p>
-            <a:pPr indent="0" marL="0">
+            <a:pPr marL="0" indent="0">
               <a:buNone/>
             </a:pPr>
             <a:r>
@@ -8022,7 +7950,7 @@
             <a:endParaRPr lang="en-US" sz="1300" dirty="0"/>
           </a:p>
           <a:p>
-            <a:pPr indent="0" marL="0">
+            <a:pPr marL="0" indent="0">
               <a:buNone/>
             </a:pPr>
             <a:r>
@@ -8039,7 +7967,7 @@
             <a:endParaRPr lang="en-US" sz="1300" dirty="0"/>
           </a:p>
           <a:p>
-            <a:pPr indent="0" marL="0">
+            <a:pPr marL="0" indent="0">
               <a:buNone/>
             </a:pPr>
             <a:r>
@@ -8106,6 +8034,13 @@
             <a:prstDash val="solid"/>
           </a:ln>
         </p:spPr>
+        <p:txBody>
+          <a:bodyPr/>
+          <a:lstStyle/>
+          <a:p>
+            <a:endParaRPr lang="es-ES"/>
+          </a:p>
+        </p:txBody>
       </p:sp>
       <p:sp>
         <p:nvSpPr>
@@ -8128,7 +8063,7 @@
           <a:bodyPr wrap="square" rtlCol="0" anchor="ctr"/>
           <a:lstStyle/>
           <a:p>
-            <a:pPr indent="0" marL="0">
+            <a:pPr marL="0" indent="0">
               <a:buNone/>
             </a:pPr>
             <a:r>
@@ -8167,7 +8102,7 @@
           <a:bodyPr wrap="square" rtlCol="0" anchor="ctr"/>
           <a:lstStyle/>
           <a:p>
-            <a:pPr algn="r" indent="0" marL="0">
+            <a:pPr marL="0" indent="0" algn="r">
               <a:buNone/>
             </a:pPr>
             <a:r>
@@ -8209,6 +8144,13 @@
             <a:prstDash val="solid"/>
           </a:ln>
         </p:spPr>
+        <p:txBody>
+          <a:bodyPr/>
+          <a:lstStyle/>
+          <a:p>
+            <a:endParaRPr lang="es-ES"/>
+          </a:p>
+        </p:txBody>
       </p:sp>
       <p:sp>
         <p:nvSpPr>
@@ -8231,7 +8173,7 @@
           <a:bodyPr wrap="square" rtlCol="0" anchor="ctr"/>
           <a:lstStyle/>
           <a:p>
-            <a:pPr indent="0" marL="0">
+            <a:pPr marL="0" indent="0">
               <a:buNone/>
             </a:pPr>
             <a:r>
@@ -8298,6 +8240,13 @@
             <a:prstDash val="solid"/>
           </a:ln>
         </p:spPr>
+        <p:txBody>
+          <a:bodyPr/>
+          <a:lstStyle/>
+          <a:p>
+            <a:endParaRPr lang="es-ES"/>
+          </a:p>
+        </p:txBody>
       </p:sp>
       <p:sp>
         <p:nvSpPr>
@@ -8320,7 +8269,7 @@
           <a:bodyPr wrap="square" rtlCol="0" anchor="ctr"/>
           <a:lstStyle/>
           <a:p>
-            <a:pPr indent="0" marL="0">
+            <a:pPr marL="0" indent="0">
               <a:buNone/>
             </a:pPr>
             <a:r>
@@ -8359,7 +8308,7 @@
           <a:bodyPr wrap="square" rtlCol="0" anchor="ctr"/>
           <a:lstStyle/>
           <a:p>
-            <a:pPr algn="r" indent="0" marL="0">
+            <a:pPr marL="0" indent="0" algn="r">
               <a:buNone/>
             </a:pPr>
             <a:r>
@@ -8398,7 +8347,7 @@
           <a:bodyPr wrap="square" rtlCol="0" anchor="t"/>
           <a:lstStyle/>
           <a:p>
-            <a:pPr indent="0" marL="0">
+            <a:pPr marL="0" indent="0">
               <a:buNone/>
             </a:pPr>
             <a:r>
@@ -8432,15 +8381,27 @@
         </p:nvGraphicFramePr>
         <p:xfrm>
           <a:off x="548640" y="2103120"/>
-          <a:ext cx="11091672" cy="914400"/>
+          <a:ext cx="11091672" cy="2743200"/>
         </p:xfrm>
         <a:graphic>
           <a:graphicData uri="http://schemas.openxmlformats.org/drawingml/2006/table">
             <a:tbl>
               <a:tblPr/>
               <a:tblGrid>
-                <a:gridCol w="4658502"/>
-                <a:gridCol w="6433170"/>
+                <a:gridCol w="4658502">
+                  <a:extLst>
+                    <a:ext uri="{9D8B030D-6E8A-4147-A177-3AD203B41FA5}">
+                      <a16:colId xmlns:a16="http://schemas.microsoft.com/office/drawing/2014/main" val="20000"/>
+                    </a:ext>
+                  </a:extLst>
+                </a:gridCol>
+                <a:gridCol w="6433170">
+                  <a:extLst>
+                    <a:ext uri="{9D8B030D-6E8A-4147-A177-3AD203B41FA5}">
+                      <a16:colId xmlns:a16="http://schemas.microsoft.com/office/drawing/2014/main" val="20001"/>
+                    </a:ext>
+                  </a:extLst>
+                </a:gridCol>
               </a:tblGrid>
               <a:tr h="914400">
                 <a:tc>
@@ -8448,7 +8409,7 @@
                     <a:bodyPr/>
                     <a:lstStyle/>
                     <a:p>
-                      <a:pPr algn="ctr" indent="0" marL="0">
+                      <a:pPr marL="0" indent="0" algn="ctr">
                         <a:buNone/>
                       </a:pPr>
                       <a:r>
@@ -8469,7 +8430,7 @@
                       </a:endParaRPr>
                     </a:p>
                   </a:txBody>
-                  <a:tcPr marL="91440" marR="91440" marT="45720" marB="45720" anchor="ctr">
+                  <a:tcPr anchor="ctr">
                     <a:lnL w="12700" cap="flat" cmpd="sng" algn="ctr">
                       <a:solidFill>
                         <a:srgbClr val="EEEEEE"/>
@@ -8516,7 +8477,7 @@
                     <a:bodyPr/>
                     <a:lstStyle/>
                     <a:p>
-                      <a:pPr algn="ctr" indent="0" marL="0">
+                      <a:pPr marL="0" indent="0" algn="ctr">
                         <a:buNone/>
                       </a:pPr>
                       <a:r>
@@ -8537,7 +8498,7 @@
                       </a:endParaRPr>
                     </a:p>
                   </a:txBody>
-                  <a:tcPr marL="91440" marR="91440" marT="45720" marB="45720" anchor="ctr">
+                  <a:tcPr anchor="ctr">
                     <a:lnL w="12700" cap="flat" cmpd="sng" algn="ctr">
                       <a:solidFill>
                         <a:srgbClr val="EEEEEE"/>
@@ -8579,6 +8540,11 @@
                     </a:solidFill>
                   </a:tcPr>
                 </a:tc>
+                <a:extLst>
+                  <a:ext uri="{0D108BD9-81ED-4DB2-BD59-A6C34878D82A}">
+                    <a16:rowId xmlns:a16="http://schemas.microsoft.com/office/drawing/2014/main" val="10000"/>
+                  </a:ext>
+                </a:extLst>
               </a:tr>
               <a:tr h="914400">
                 <a:tc>
@@ -8586,7 +8552,7 @@
                     <a:bodyPr/>
                     <a:lstStyle/>
                     <a:p>
-                      <a:pPr indent="0" marL="0">
+                      <a:pPr marL="0" indent="0">
                         <a:buNone/>
                       </a:pPr>
                       <a:r>
@@ -8607,7 +8573,7 @@
                       </a:endParaRPr>
                     </a:p>
                   </a:txBody>
-                  <a:tcPr marL="91440" marR="91440" marT="45720" marB="45720" anchor="ctr">
+                  <a:tcPr anchor="ctr">
                     <a:lnL w="12700" cap="flat" cmpd="sng" algn="ctr">
                       <a:solidFill>
                         <a:srgbClr val="EEEEEE"/>
@@ -8654,7 +8620,7 @@
                     <a:bodyPr/>
                     <a:lstStyle/>
                     <a:p>
-                      <a:pPr indent="0" marL="0">
+                      <a:pPr marL="0" indent="0">
                         <a:buNone/>
                       </a:pPr>
                       <a:r>
@@ -8675,7 +8641,7 @@
                       </a:endParaRPr>
                     </a:p>
                   </a:txBody>
-                  <a:tcPr marL="91440" marR="91440" marT="45720" marB="45720" anchor="ctr">
+                  <a:tcPr anchor="ctr">
                     <a:lnL w="12700" cap="flat" cmpd="sng" algn="ctr">
                       <a:solidFill>
                         <a:srgbClr val="EEEEEE"/>
@@ -8717,6 +8683,11 @@
                     </a:solidFill>
                   </a:tcPr>
                 </a:tc>
+                <a:extLst>
+                  <a:ext uri="{0D108BD9-81ED-4DB2-BD59-A6C34878D82A}">
+                    <a16:rowId xmlns:a16="http://schemas.microsoft.com/office/drawing/2014/main" val="10001"/>
+                  </a:ext>
+                </a:extLst>
               </a:tr>
               <a:tr h="914400">
                 <a:tc>
@@ -8724,7 +8695,7 @@
                     <a:bodyPr/>
                     <a:lstStyle/>
                     <a:p>
-                      <a:pPr indent="0" marL="0">
+                      <a:pPr marL="0" indent="0">
                         <a:buNone/>
                       </a:pPr>
                       <a:r>
@@ -8745,7 +8716,7 @@
                       </a:endParaRPr>
                     </a:p>
                   </a:txBody>
-                  <a:tcPr marL="91440" marR="91440" marT="45720" marB="45720" anchor="ctr">
+                  <a:tcPr anchor="ctr">
                     <a:lnL w="12700" cap="flat" cmpd="sng" algn="ctr">
                       <a:solidFill>
                         <a:srgbClr val="EEEEEE"/>
@@ -8792,7 +8763,7 @@
                     <a:bodyPr/>
                     <a:lstStyle/>
                     <a:p>
-                      <a:pPr indent="0" marL="0">
+                      <a:pPr marL="0" indent="0">
                         <a:buNone/>
                       </a:pPr>
                       <a:r>
@@ -8813,7 +8784,7 @@
                       </a:endParaRPr>
                     </a:p>
                   </a:txBody>
-                  <a:tcPr marL="91440" marR="91440" marT="45720" marB="45720" anchor="ctr">
+                  <a:tcPr anchor="ctr">
                     <a:lnL w="12700" cap="flat" cmpd="sng" algn="ctr">
                       <a:solidFill>
                         <a:srgbClr val="EEEEEE"/>
@@ -8855,6 +8826,11 @@
                     </a:solidFill>
                   </a:tcPr>
                 </a:tc>
+                <a:extLst>
+                  <a:ext uri="{0D108BD9-81ED-4DB2-BD59-A6C34878D82A}">
+                    <a16:rowId xmlns:a16="http://schemas.microsoft.com/office/drawing/2014/main" val="10002"/>
+                  </a:ext>
+                </a:extLst>
               </a:tr>
             </a:tbl>
           </a:graphicData>
@@ -8909,6 +8885,13 @@
             <a:prstDash val="solid"/>
           </a:ln>
         </p:spPr>
+        <p:txBody>
+          <a:bodyPr/>
+          <a:lstStyle/>
+          <a:p>
+            <a:endParaRPr lang="es-ES"/>
+          </a:p>
+        </p:txBody>
       </p:sp>
       <p:sp>
         <p:nvSpPr>
@@ -8931,7 +8914,7 @@
           <a:bodyPr wrap="square" rtlCol="0" anchor="ctr"/>
           <a:lstStyle/>
           <a:p>
-            <a:pPr indent="0" marL="0">
+            <a:pPr marL="0" indent="0">
               <a:buNone/>
             </a:pPr>
             <a:r>
@@ -8970,7 +8953,7 @@
           <a:bodyPr wrap="square" rtlCol="0" anchor="ctr"/>
           <a:lstStyle/>
           <a:p>
-            <a:pPr algn="r" indent="0" marL="0">
+            <a:pPr marL="0" indent="0" algn="r">
               <a:buNone/>
             </a:pPr>
             <a:r>
@@ -9012,6 +8995,13 @@
             <a:prstDash val="solid"/>
           </a:ln>
         </p:spPr>
+        <p:txBody>
+          <a:bodyPr/>
+          <a:lstStyle/>
+          <a:p>
+            <a:endParaRPr lang="es-ES"/>
+          </a:p>
+        </p:txBody>
       </p:sp>
       <p:sp>
         <p:nvSpPr>
@@ -9037,6 +9027,13 @@
             <a:prstDash val="solid"/>
           </a:ln>
         </p:spPr>
+        <p:txBody>
+          <a:bodyPr/>
+          <a:lstStyle/>
+          <a:p>
+            <a:endParaRPr lang="es-ES"/>
+          </a:p>
+        </p:txBody>
       </p:sp>
       <p:sp>
         <p:nvSpPr>
@@ -9059,7 +9056,7 @@
           <a:bodyPr wrap="square" rtlCol="0" anchor="t"/>
           <a:lstStyle/>
           <a:p>
-            <a:pPr indent="0" marL="0">
+            <a:pPr marL="0" indent="0">
               <a:buNone/>
             </a:pPr>
             <a:r>
@@ -9076,7 +9073,7 @@
             <a:endParaRPr lang="en-US" sz="1250" dirty="0"/>
           </a:p>
           <a:p>
-            <a:pPr indent="0" marL="0">
+            <a:pPr marL="0" indent="0">
               <a:buNone/>
             </a:pPr>
             <a:r>
@@ -9093,7 +9090,7 @@
             <a:endParaRPr lang="en-US" sz="1250" dirty="0"/>
           </a:p>
           <a:p>
-            <a:pPr indent="0" marL="0">
+            <a:pPr marL="0" indent="0">
               <a:buNone/>
             </a:pPr>
             <a:r>
@@ -9110,13 +9107,13 @@
             <a:endParaRPr lang="en-US" sz="1250" dirty="0"/>
           </a:p>
           <a:p>
-            <a:pPr indent="0" marL="0">
+            <a:pPr marL="0" indent="0">
               <a:buNone/>
             </a:pPr>
             <a:endParaRPr lang="en-US" sz="1250" dirty="0"/>
           </a:p>
           <a:p>
-            <a:pPr indent="0" marL="0">
+            <a:pPr marL="0" indent="0">
               <a:buNone/>
             </a:pPr>
             <a:r>
@@ -9133,7 +9130,7 @@
             <a:endParaRPr lang="en-US" sz="1250" dirty="0"/>
           </a:p>
           <a:p>
-            <a:pPr indent="0" marL="0">
+            <a:pPr marL="0" indent="0">
               <a:buNone/>
             </a:pPr>
             <a:r>
@@ -9150,7 +9147,7 @@
             <a:endParaRPr lang="en-US" sz="1250" dirty="0"/>
           </a:p>
           <a:p>
-            <a:pPr indent="0" marL="0">
+            <a:pPr marL="0" indent="0">
               <a:buNone/>
             </a:pPr>
             <a:r>
@@ -9167,7 +9164,7 @@
             <a:endParaRPr lang="en-US" sz="1250" dirty="0"/>
           </a:p>
           <a:p>
-            <a:pPr indent="0" marL="0">
+            <a:pPr marL="0" indent="0">
               <a:buNone/>
             </a:pPr>
             <a:r>
@@ -9184,7 +9181,7 @@
             <a:endParaRPr lang="en-US" sz="1250" dirty="0"/>
           </a:p>
           <a:p>
-            <a:pPr indent="0" marL="0">
+            <a:pPr marL="0" indent="0">
               <a:buNone/>
             </a:pPr>
             <a:r>
@@ -9201,7 +9198,7 @@
             <a:endParaRPr lang="en-US" sz="1250" dirty="0"/>
           </a:p>
           <a:p>
-            <a:pPr indent="0" marL="0">
+            <a:pPr marL="0" indent="0">
               <a:buNone/>
             </a:pPr>
             <a:r>
@@ -9218,7 +9215,7 @@
             <a:endParaRPr lang="en-US" sz="1250" dirty="0"/>
           </a:p>
           <a:p>
-            <a:pPr indent="0" marL="0">
+            <a:pPr marL="0" indent="0">
               <a:buNone/>
             </a:pPr>
             <a:r>
@@ -9257,7 +9254,7 @@
           <a:bodyPr wrap="square" rtlCol="0" anchor="t"/>
           <a:lstStyle/>
           <a:p>
-            <a:pPr indent="0" marL="0">
+            <a:pPr marL="0" indent="0">
               <a:buNone/>
             </a:pPr>
             <a:r>
@@ -9324,6 +9321,13 @@
             <a:prstDash val="solid"/>
           </a:ln>
         </p:spPr>
+        <p:txBody>
+          <a:bodyPr/>
+          <a:lstStyle/>
+          <a:p>
+            <a:endParaRPr lang="es-ES"/>
+          </a:p>
+        </p:txBody>
       </p:sp>
       <p:sp>
         <p:nvSpPr>
@@ -9346,7 +9350,7 @@
           <a:bodyPr wrap="square" rtlCol="0" anchor="ctr"/>
           <a:lstStyle/>
           <a:p>
-            <a:pPr indent="0" marL="0">
+            <a:pPr marL="0" indent="0">
               <a:buNone/>
             </a:pPr>
             <a:r>
@@ -9385,7 +9389,7 @@
           <a:bodyPr wrap="square" rtlCol="0" anchor="ctr"/>
           <a:lstStyle/>
           <a:p>
-            <a:pPr algn="r" indent="0" marL="0">
+            <a:pPr marL="0" indent="0" algn="r">
               <a:buNone/>
             </a:pPr>
             <a:r>
@@ -9424,7 +9428,7 @@
           <a:bodyPr wrap="square" rtlCol="0" anchor="t"/>
           <a:lstStyle/>
           <a:p>
-            <a:pPr indent="0" marL="0">
+            <a:pPr marL="0" indent="0">
               <a:buNone/>
             </a:pPr>
             <a:r>
@@ -9466,6 +9470,13 @@
             <a:prstDash val="solid"/>
           </a:ln>
         </p:spPr>
+        <p:txBody>
+          <a:bodyPr/>
+          <a:lstStyle/>
+          <a:p>
+            <a:endParaRPr lang="es-ES"/>
+          </a:p>
+        </p:txBody>
       </p:sp>
       <p:sp>
         <p:nvSpPr>
@@ -9491,6 +9502,13 @@
             <a:prstDash val="solid"/>
           </a:ln>
         </p:spPr>
+        <p:txBody>
+          <a:bodyPr/>
+          <a:lstStyle/>
+          <a:p>
+            <a:endParaRPr lang="es-ES"/>
+          </a:p>
+        </p:txBody>
       </p:sp>
       <p:sp>
         <p:nvSpPr>
@@ -9513,7 +9531,7 @@
           <a:bodyPr wrap="square" rtlCol="0" anchor="t"/>
           <a:lstStyle/>
           <a:p>
-            <a:pPr indent="0" marL="0">
+            <a:pPr marL="0" indent="0">
               <a:buNone/>
             </a:pPr>
             <a:r>
@@ -9530,7 +9548,7 @@
             <a:endParaRPr lang="en-US" sz="1350" dirty="0"/>
           </a:p>
           <a:p>
-            <a:pPr indent="0" marL="0">
+            <a:pPr marL="0" indent="0">
               <a:buNone/>
             </a:pPr>
             <a:r>
@@ -9547,7 +9565,7 @@
             <a:endParaRPr lang="en-US" sz="1350" dirty="0"/>
           </a:p>
           <a:p>
-            <a:pPr indent="0" marL="0">
+            <a:pPr marL="0" indent="0">
               <a:buNone/>
             </a:pPr>
             <a:r>
@@ -9564,13 +9582,13 @@
             <a:endParaRPr lang="en-US" sz="1350" dirty="0"/>
           </a:p>
           <a:p>
-            <a:pPr indent="0" marL="0">
+            <a:pPr marL="0" indent="0">
               <a:buNone/>
             </a:pPr>
             <a:endParaRPr lang="en-US" sz="1350" dirty="0"/>
           </a:p>
           <a:p>
-            <a:pPr indent="0" marL="0">
+            <a:pPr marL="0" indent="0">
               <a:buNone/>
             </a:pPr>
             <a:r>
@@ -9587,7 +9605,7 @@
             <a:endParaRPr lang="en-US" sz="1350" dirty="0"/>
           </a:p>
           <a:p>
-            <a:pPr indent="0" marL="0">
+            <a:pPr marL="0" indent="0">
               <a:buNone/>
             </a:pPr>
             <a:r>
@@ -9604,7 +9622,7 @@
             <a:endParaRPr lang="en-US" sz="1350" dirty="0"/>
           </a:p>
           <a:p>
-            <a:pPr indent="0" marL="0">
+            <a:pPr marL="0" indent="0">
               <a:buNone/>
             </a:pPr>
             <a:r>
@@ -9621,7 +9639,7 @@
             <a:endParaRPr lang="en-US" sz="1350" dirty="0"/>
           </a:p>
           <a:p>
-            <a:pPr indent="0" marL="0">
+            <a:pPr marL="0" indent="0">
               <a:buNone/>
             </a:pPr>
             <a:r>
@@ -9638,7 +9656,7 @@
             <a:endParaRPr lang="en-US" sz="1350" dirty="0"/>
           </a:p>
           <a:p>
-            <a:pPr indent="0" marL="0">
+            <a:pPr marL="0" indent="0">
               <a:buNone/>
             </a:pPr>
             <a:r>
@@ -9665,7 +9683,7 @@
         <p:spPr>
           <a:xfrm>
             <a:off x="548640" y="4526280"/>
-            <a:ext cx="11091672" cy="1051560"/>
+            <a:ext cx="11091672" cy="1268030"/>
           </a:xfrm>
           <a:prstGeom prst="roundRect">
             <a:avLst/>
@@ -9680,6 +9698,13 @@
             <a:prstDash val="solid"/>
           </a:ln>
         </p:spPr>
+        <p:txBody>
+          <a:bodyPr/>
+          <a:lstStyle/>
+          <a:p>
+            <a:endParaRPr lang="es-ES"/>
+          </a:p>
+        </p:txBody>
       </p:sp>
       <p:sp>
         <p:nvSpPr>
@@ -9702,7 +9727,7 @@
           <a:bodyPr wrap="square" rtlCol="0" anchor="t"/>
           <a:lstStyle/>
           <a:p>
-            <a:pPr indent="0" marL="0">
+            <a:pPr marL="0" indent="0">
               <a:buNone/>
             </a:pPr>
             <a:r>
@@ -9720,7 +9745,7 @@
             <a:endParaRPr lang="en-US" sz="1550" dirty="0"/>
           </a:p>
           <a:p>
-            <a:pPr indent="0" marL="0">
+            <a:pPr marL="0" indent="0">
               <a:buNone/>
             </a:pPr>
             <a:r>
@@ -9787,6 +9812,13 @@
             <a:prstDash val="solid"/>
           </a:ln>
         </p:spPr>
+        <p:txBody>
+          <a:bodyPr/>
+          <a:lstStyle/>
+          <a:p>
+            <a:endParaRPr lang="es-ES"/>
+          </a:p>
+        </p:txBody>
       </p:sp>
       <p:sp>
         <p:nvSpPr>
@@ -9809,7 +9841,7 @@
           <a:bodyPr wrap="square" rtlCol="0" anchor="ctr"/>
           <a:lstStyle/>
           <a:p>
-            <a:pPr indent="0" marL="0">
+            <a:pPr marL="0" indent="0">
               <a:buNone/>
             </a:pPr>
             <a:r>
@@ -9848,7 +9880,7 @@
           <a:bodyPr wrap="square" rtlCol="0" anchor="ctr"/>
           <a:lstStyle/>
           <a:p>
-            <a:pPr algn="r" indent="0" marL="0">
+            <a:pPr marL="0" indent="0" algn="r">
               <a:buNone/>
             </a:pPr>
             <a:r>
@@ -9882,16 +9914,34 @@
         </p:nvGraphicFramePr>
         <p:xfrm>
           <a:off x="548640" y="1371600"/>
-          <a:ext cx="11091672" cy="914400"/>
+          <a:ext cx="11091671" cy="3950208"/>
         </p:xfrm>
         <a:graphic>
           <a:graphicData uri="http://schemas.openxmlformats.org/drawingml/2006/table">
             <a:tbl>
               <a:tblPr/>
               <a:tblGrid>
-                <a:gridCol w="3549335"/>
-                <a:gridCol w="3771168"/>
-                <a:gridCol w="3771168"/>
+                <a:gridCol w="3549335">
+                  <a:extLst>
+                    <a:ext uri="{9D8B030D-6E8A-4147-A177-3AD203B41FA5}">
+                      <a16:colId xmlns:a16="http://schemas.microsoft.com/office/drawing/2014/main" val="20000"/>
+                    </a:ext>
+                  </a:extLst>
+                </a:gridCol>
+                <a:gridCol w="3771168">
+                  <a:extLst>
+                    <a:ext uri="{9D8B030D-6E8A-4147-A177-3AD203B41FA5}">
+                      <a16:colId xmlns:a16="http://schemas.microsoft.com/office/drawing/2014/main" val="20001"/>
+                    </a:ext>
+                  </a:extLst>
+                </a:gridCol>
+                <a:gridCol w="3771168">
+                  <a:extLst>
+                    <a:ext uri="{9D8B030D-6E8A-4147-A177-3AD203B41FA5}">
+                      <a16:colId xmlns:a16="http://schemas.microsoft.com/office/drawing/2014/main" val="20002"/>
+                    </a:ext>
+                  </a:extLst>
+                </a:gridCol>
               </a:tblGrid>
               <a:tr h="658368">
                 <a:tc>
@@ -9899,7 +9949,7 @@
                     <a:bodyPr/>
                     <a:lstStyle/>
                     <a:p>
-                      <a:pPr algn="ctr" indent="0" marL="0">
+                      <a:pPr marL="0" indent="0" algn="ctr">
                         <a:buNone/>
                       </a:pPr>
                       <a:r>
@@ -9920,7 +9970,7 @@
                       </a:endParaRPr>
                     </a:p>
                   </a:txBody>
-                  <a:tcPr marL="91440" marR="91440" marT="45720" marB="45720" anchor="ctr">
+                  <a:tcPr anchor="ctr">
                     <a:lnL w="12700" cap="flat" cmpd="sng" algn="ctr">
                       <a:solidFill>
                         <a:srgbClr val="EEEEEE"/>
@@ -9967,7 +10017,7 @@
                     <a:bodyPr/>
                     <a:lstStyle/>
                     <a:p>
-                      <a:pPr algn="ctr" indent="0" marL="0">
+                      <a:pPr marL="0" indent="0" algn="ctr">
                         <a:buNone/>
                       </a:pPr>
                       <a:r>
@@ -9988,7 +10038,7 @@
                       </a:endParaRPr>
                     </a:p>
                   </a:txBody>
-                  <a:tcPr marL="91440" marR="91440" marT="45720" marB="45720" anchor="ctr">
+                  <a:tcPr anchor="ctr">
                     <a:lnL w="12700" cap="flat" cmpd="sng" algn="ctr">
                       <a:solidFill>
                         <a:srgbClr val="EEEEEE"/>
@@ -10035,7 +10085,7 @@
                     <a:bodyPr/>
                     <a:lstStyle/>
                     <a:p>
-                      <a:pPr algn="ctr" indent="0" marL="0">
+                      <a:pPr marL="0" indent="0" algn="ctr">
                         <a:buNone/>
                       </a:pPr>
                       <a:r>
@@ -10056,7 +10106,7 @@
                       </a:endParaRPr>
                     </a:p>
                   </a:txBody>
-                  <a:tcPr marL="91440" marR="91440" marT="45720" marB="45720" anchor="ctr">
+                  <a:tcPr anchor="ctr">
                     <a:lnL w="12700" cap="flat" cmpd="sng" algn="ctr">
                       <a:solidFill>
                         <a:srgbClr val="EEEEEE"/>
@@ -10098,6 +10148,11 @@
                     </a:solidFill>
                   </a:tcPr>
                 </a:tc>
+                <a:extLst>
+                  <a:ext uri="{0D108BD9-81ED-4DB2-BD59-A6C34878D82A}">
+                    <a16:rowId xmlns:a16="http://schemas.microsoft.com/office/drawing/2014/main" val="10000"/>
+                  </a:ext>
+                </a:extLst>
               </a:tr>
               <a:tr h="658368">
                 <a:tc>
@@ -10105,7 +10160,7 @@
                     <a:bodyPr/>
                     <a:lstStyle/>
                     <a:p>
-                      <a:pPr indent="0" marL="0">
+                      <a:pPr marL="0" indent="0">
                         <a:buNone/>
                       </a:pPr>
                       <a:r>
@@ -10126,7 +10181,7 @@
                       </a:endParaRPr>
                     </a:p>
                   </a:txBody>
-                  <a:tcPr marL="91440" marR="91440" marT="45720" marB="45720" anchor="ctr">
+                  <a:tcPr anchor="ctr">
                     <a:lnL w="12700" cap="flat" cmpd="sng" algn="ctr">
                       <a:solidFill>
                         <a:srgbClr val="EEEEEE"/>
@@ -10173,7 +10228,7 @@
                     <a:bodyPr/>
                     <a:lstStyle/>
                     <a:p>
-                      <a:pPr indent="0" marL="0">
+                      <a:pPr marL="0" indent="0">
                         <a:buNone/>
                       </a:pPr>
                       <a:r>
@@ -10194,7 +10249,7 @@
                       </a:endParaRPr>
                     </a:p>
                   </a:txBody>
-                  <a:tcPr marL="91440" marR="91440" marT="45720" marB="45720" anchor="ctr">
+                  <a:tcPr anchor="ctr">
                     <a:lnL w="12700" cap="flat" cmpd="sng" algn="ctr">
                       <a:solidFill>
                         <a:srgbClr val="EEEEEE"/>
@@ -10241,7 +10296,7 @@
                     <a:bodyPr/>
                     <a:lstStyle/>
                     <a:p>
-                      <a:pPr indent="0" marL="0">
+                      <a:pPr marL="0" indent="0">
                         <a:buNone/>
                       </a:pPr>
                       <a:r>
@@ -10262,7 +10317,7 @@
                       </a:endParaRPr>
                     </a:p>
                   </a:txBody>
-                  <a:tcPr marL="91440" marR="91440" marT="45720" marB="45720" anchor="ctr">
+                  <a:tcPr anchor="ctr">
                     <a:lnL w="12700" cap="flat" cmpd="sng" algn="ctr">
                       <a:solidFill>
                         <a:srgbClr val="EEEEEE"/>
@@ -10304,6 +10359,11 @@
                     </a:solidFill>
                   </a:tcPr>
                 </a:tc>
+                <a:extLst>
+                  <a:ext uri="{0D108BD9-81ED-4DB2-BD59-A6C34878D82A}">
+                    <a16:rowId xmlns:a16="http://schemas.microsoft.com/office/drawing/2014/main" val="10001"/>
+                  </a:ext>
+                </a:extLst>
               </a:tr>
               <a:tr h="658368">
                 <a:tc>
@@ -10311,7 +10371,7 @@
                     <a:bodyPr/>
                     <a:lstStyle/>
                     <a:p>
-                      <a:pPr indent="0" marL="0">
+                      <a:pPr marL="0" indent="0">
                         <a:buNone/>
                       </a:pPr>
                       <a:r>
@@ -10332,7 +10392,7 @@
                       </a:endParaRPr>
                     </a:p>
                   </a:txBody>
-                  <a:tcPr marL="91440" marR="91440" marT="45720" marB="45720" anchor="ctr">
+                  <a:tcPr anchor="ctr">
                     <a:lnL w="12700" cap="flat" cmpd="sng" algn="ctr">
                       <a:solidFill>
                         <a:srgbClr val="EEEEEE"/>
@@ -10379,7 +10439,7 @@
                     <a:bodyPr/>
                     <a:lstStyle/>
                     <a:p>
-                      <a:pPr indent="0" marL="0">
+                      <a:pPr marL="0" indent="0">
                         <a:buNone/>
                       </a:pPr>
                       <a:r>
@@ -10400,7 +10460,7 @@
                       </a:endParaRPr>
                     </a:p>
                   </a:txBody>
-                  <a:tcPr marL="91440" marR="91440" marT="45720" marB="45720" anchor="ctr">
+                  <a:tcPr anchor="ctr">
                     <a:lnL w="12700" cap="flat" cmpd="sng" algn="ctr">
                       <a:solidFill>
                         <a:srgbClr val="EEEEEE"/>
@@ -10447,7 +10507,7 @@
                     <a:bodyPr/>
                     <a:lstStyle/>
                     <a:p>
-                      <a:pPr indent="0" marL="0">
+                      <a:pPr marL="0" indent="0">
                         <a:buNone/>
                       </a:pPr>
                       <a:r>
@@ -10468,7 +10528,7 @@
                       </a:endParaRPr>
                     </a:p>
                   </a:txBody>
-                  <a:tcPr marL="91440" marR="91440" marT="45720" marB="45720" anchor="ctr">
+                  <a:tcPr anchor="ctr">
                     <a:lnL w="12700" cap="flat" cmpd="sng" algn="ctr">
                       <a:solidFill>
                         <a:srgbClr val="EEEEEE"/>
@@ -10510,6 +10570,11 @@
                     </a:solidFill>
                   </a:tcPr>
                 </a:tc>
+                <a:extLst>
+                  <a:ext uri="{0D108BD9-81ED-4DB2-BD59-A6C34878D82A}">
+                    <a16:rowId xmlns:a16="http://schemas.microsoft.com/office/drawing/2014/main" val="10002"/>
+                  </a:ext>
+                </a:extLst>
               </a:tr>
               <a:tr h="658368">
                 <a:tc>
@@ -10517,7 +10582,7 @@
                     <a:bodyPr/>
                     <a:lstStyle/>
                     <a:p>
-                      <a:pPr indent="0" marL="0">
+                      <a:pPr marL="0" indent="0">
                         <a:buNone/>
                       </a:pPr>
                       <a:r>
@@ -10538,7 +10603,7 @@
                       </a:endParaRPr>
                     </a:p>
                   </a:txBody>
-                  <a:tcPr marL="91440" marR="91440" marT="45720" marB="45720" anchor="ctr">
+                  <a:tcPr anchor="ctr">
                     <a:lnL w="12700" cap="flat" cmpd="sng" algn="ctr">
                       <a:solidFill>
                         <a:srgbClr val="EEEEEE"/>
@@ -10585,7 +10650,7 @@
                     <a:bodyPr/>
                     <a:lstStyle/>
                     <a:p>
-                      <a:pPr indent="0" marL="0">
+                      <a:pPr marL="0" indent="0">
                         <a:buNone/>
                       </a:pPr>
                       <a:r>
@@ -10606,7 +10671,7 @@
                       </a:endParaRPr>
                     </a:p>
                   </a:txBody>
-                  <a:tcPr marL="91440" marR="91440" marT="45720" marB="45720" anchor="ctr">
+                  <a:tcPr anchor="ctr">
                     <a:lnL w="12700" cap="flat" cmpd="sng" algn="ctr">
                       <a:solidFill>
                         <a:srgbClr val="EEEEEE"/>
@@ -10653,7 +10718,7 @@
                     <a:bodyPr/>
                     <a:lstStyle/>
                     <a:p>
-                      <a:pPr indent="0" marL="0">
+                      <a:pPr marL="0" indent="0">
                         <a:buNone/>
                       </a:pPr>
                       <a:r>
@@ -10674,7 +10739,7 @@
                       </a:endParaRPr>
                     </a:p>
                   </a:txBody>
-                  <a:tcPr marL="91440" marR="91440" marT="45720" marB="45720" anchor="ctr">
+                  <a:tcPr anchor="ctr">
                     <a:lnL w="12700" cap="flat" cmpd="sng" algn="ctr">
                       <a:solidFill>
                         <a:srgbClr val="EEEEEE"/>
@@ -10716,6 +10781,11 @@
                     </a:solidFill>
                   </a:tcPr>
                 </a:tc>
+                <a:extLst>
+                  <a:ext uri="{0D108BD9-81ED-4DB2-BD59-A6C34878D82A}">
+                    <a16:rowId xmlns:a16="http://schemas.microsoft.com/office/drawing/2014/main" val="10003"/>
+                  </a:ext>
+                </a:extLst>
               </a:tr>
               <a:tr h="658368">
                 <a:tc>
@@ -10723,7 +10793,7 @@
                     <a:bodyPr/>
                     <a:lstStyle/>
                     <a:p>
-                      <a:pPr indent="0" marL="0">
+                      <a:pPr marL="0" indent="0">
                         <a:buNone/>
                       </a:pPr>
                       <a:r>
@@ -10744,7 +10814,7 @@
                       </a:endParaRPr>
                     </a:p>
                   </a:txBody>
-                  <a:tcPr marL="91440" marR="91440" marT="45720" marB="45720" anchor="ctr">
+                  <a:tcPr anchor="ctr">
                     <a:lnL w="12700" cap="flat" cmpd="sng" algn="ctr">
                       <a:solidFill>
                         <a:srgbClr val="EEEEEE"/>
@@ -10791,7 +10861,7 @@
                     <a:bodyPr/>
                     <a:lstStyle/>
                     <a:p>
-                      <a:pPr indent="0" marL="0">
+                      <a:pPr marL="0" indent="0">
                         <a:buNone/>
                       </a:pPr>
                       <a:r>
@@ -10812,7 +10882,7 @@
                       </a:endParaRPr>
                     </a:p>
                   </a:txBody>
-                  <a:tcPr marL="91440" marR="91440" marT="45720" marB="45720" anchor="ctr">
+                  <a:tcPr anchor="ctr">
                     <a:lnL w="12700" cap="flat" cmpd="sng" algn="ctr">
                       <a:solidFill>
                         <a:srgbClr val="EEEEEE"/>
@@ -10859,7 +10929,7 @@
                     <a:bodyPr/>
                     <a:lstStyle/>
                     <a:p>
-                      <a:pPr indent="0" marL="0">
+                      <a:pPr marL="0" indent="0">
                         <a:buNone/>
                       </a:pPr>
                       <a:r>
@@ -10880,7 +10950,7 @@
                       </a:endParaRPr>
                     </a:p>
                   </a:txBody>
-                  <a:tcPr marL="91440" marR="91440" marT="45720" marB="45720" anchor="ctr">
+                  <a:tcPr anchor="ctr">
                     <a:lnL w="12700" cap="flat" cmpd="sng" algn="ctr">
                       <a:solidFill>
                         <a:srgbClr val="EEEEEE"/>
@@ -10922,6 +10992,11 @@
                     </a:solidFill>
                   </a:tcPr>
                 </a:tc>
+                <a:extLst>
+                  <a:ext uri="{0D108BD9-81ED-4DB2-BD59-A6C34878D82A}">
+                    <a16:rowId xmlns:a16="http://schemas.microsoft.com/office/drawing/2014/main" val="10004"/>
+                  </a:ext>
+                </a:extLst>
               </a:tr>
               <a:tr h="658368">
                 <a:tc>
@@ -10929,7 +11004,7 @@
                     <a:bodyPr/>
                     <a:lstStyle/>
                     <a:p>
-                      <a:pPr indent="0" marL="0">
+                      <a:pPr marL="0" indent="0">
                         <a:buNone/>
                       </a:pPr>
                       <a:r>
@@ -10950,7 +11025,7 @@
                       </a:endParaRPr>
                     </a:p>
                   </a:txBody>
-                  <a:tcPr marL="91440" marR="91440" marT="45720" marB="45720" anchor="ctr">
+                  <a:tcPr anchor="ctr">
                     <a:lnL w="12700" cap="flat" cmpd="sng" algn="ctr">
                       <a:solidFill>
                         <a:srgbClr val="EEEEEE"/>
@@ -10997,7 +11072,7 @@
                     <a:bodyPr/>
                     <a:lstStyle/>
                     <a:p>
-                      <a:pPr indent="0" marL="0">
+                      <a:pPr marL="0" indent="0">
                         <a:buNone/>
                       </a:pPr>
                       <a:r>
@@ -11018,7 +11093,7 @@
                       </a:endParaRPr>
                     </a:p>
                   </a:txBody>
-                  <a:tcPr marL="91440" marR="91440" marT="45720" marB="45720" anchor="ctr">
+                  <a:tcPr anchor="ctr">
                     <a:lnL w="12700" cap="flat" cmpd="sng" algn="ctr">
                       <a:solidFill>
                         <a:srgbClr val="EEEEEE"/>
@@ -11065,7 +11140,7 @@
                     <a:bodyPr/>
                     <a:lstStyle/>
                     <a:p>
-                      <a:pPr indent="0" marL="0">
+                      <a:pPr marL="0" indent="0">
                         <a:buNone/>
                       </a:pPr>
                       <a:r>
@@ -11086,7 +11161,7 @@
                       </a:endParaRPr>
                     </a:p>
                   </a:txBody>
-                  <a:tcPr marL="91440" marR="91440" marT="45720" marB="45720" anchor="ctr">
+                  <a:tcPr anchor="ctr">
                     <a:lnL w="12700" cap="flat" cmpd="sng" algn="ctr">
                       <a:solidFill>
                         <a:srgbClr val="EEEEEE"/>
@@ -11128,6 +11203,11 @@
                     </a:solidFill>
                   </a:tcPr>
                 </a:tc>
+                <a:extLst>
+                  <a:ext uri="{0D108BD9-81ED-4DB2-BD59-A6C34878D82A}">
+                    <a16:rowId xmlns:a16="http://schemas.microsoft.com/office/drawing/2014/main" val="10005"/>
+                  </a:ext>
+                </a:extLst>
               </a:tr>
             </a:tbl>
           </a:graphicData>
@@ -11182,6 +11262,13 @@
             <a:prstDash val="solid"/>
           </a:ln>
         </p:spPr>
+        <p:txBody>
+          <a:bodyPr/>
+          <a:lstStyle/>
+          <a:p>
+            <a:endParaRPr lang="es-ES"/>
+          </a:p>
+        </p:txBody>
       </p:sp>
       <p:sp>
         <p:nvSpPr>
@@ -11204,7 +11291,7 @@
           <a:bodyPr wrap="square" rtlCol="0" anchor="ctr"/>
           <a:lstStyle/>
           <a:p>
-            <a:pPr indent="0" marL="0">
+            <a:pPr marL="0" indent="0">
               <a:buNone/>
             </a:pPr>
             <a:r>
@@ -11243,7 +11330,7 @@
           <a:bodyPr wrap="square" rtlCol="0" anchor="ctr"/>
           <a:lstStyle/>
           <a:p>
-            <a:pPr algn="r" indent="0" marL="0">
+            <a:pPr marL="0" indent="0" algn="r">
               <a:buNone/>
             </a:pPr>
             <a:r>
@@ -11285,6 +11372,13 @@
             <a:prstDash val="solid"/>
           </a:ln>
         </p:spPr>
+        <p:txBody>
+          <a:bodyPr/>
+          <a:lstStyle/>
+          <a:p>
+            <a:endParaRPr lang="es-ES"/>
+          </a:p>
+        </p:txBody>
       </p:sp>
       <p:sp>
         <p:nvSpPr>
@@ -11307,7 +11401,7 @@
           <a:bodyPr wrap="square" rtlCol="0" anchor="ctr"/>
           <a:lstStyle/>
           <a:p>
-            <a:pPr indent="0" marL="0">
+            <a:pPr marL="0" indent="0">
               <a:buNone/>
             </a:pPr>
             <a:r>
@@ -11374,6 +11468,13 @@
             <a:prstDash val="solid"/>
           </a:ln>
         </p:spPr>
+        <p:txBody>
+          <a:bodyPr/>
+          <a:lstStyle/>
+          <a:p>
+            <a:endParaRPr lang="es-ES"/>
+          </a:p>
+        </p:txBody>
       </p:sp>
       <p:sp>
         <p:nvSpPr>
@@ -11396,7 +11497,7 @@
           <a:bodyPr wrap="square" rtlCol="0" anchor="ctr"/>
           <a:lstStyle/>
           <a:p>
-            <a:pPr indent="0" marL="0">
+            <a:pPr marL="0" indent="0">
               <a:buNone/>
             </a:pPr>
             <a:r>
@@ -11435,7 +11536,7 @@
           <a:bodyPr wrap="square" rtlCol="0" anchor="ctr"/>
           <a:lstStyle/>
           <a:p>
-            <a:pPr algn="r" indent="0" marL="0">
+            <a:pPr marL="0" indent="0" algn="r">
               <a:buNone/>
             </a:pPr>
             <a:r>
@@ -11605,6 +11706,13 @@
             <a:prstDash val="solid"/>
           </a:ln>
         </p:spPr>
+        <p:txBody>
+          <a:bodyPr/>
+          <a:lstStyle/>
+          <a:p>
+            <a:endParaRPr lang="es-ES"/>
+          </a:p>
+        </p:txBody>
       </p:sp>
       <p:sp>
         <p:nvSpPr>
@@ -11627,7 +11735,7 @@
           <a:bodyPr wrap="square" rtlCol="0" anchor="ctr"/>
           <a:lstStyle/>
           <a:p>
-            <a:pPr indent="0" marL="0">
+            <a:pPr marL="0" indent="0">
               <a:buNone/>
             </a:pPr>
             <a:r>
@@ -11666,7 +11774,7 @@
           <a:bodyPr wrap="square" rtlCol="0" anchor="ctr"/>
           <a:lstStyle/>
           <a:p>
-            <a:pPr algn="r" indent="0" marL="0">
+            <a:pPr marL="0" indent="0" algn="r">
               <a:buNone/>
             </a:pPr>
             <a:r>
@@ -11794,6 +11902,13 @@
             <a:prstDash val="solid"/>
           </a:ln>
         </p:spPr>
+        <p:txBody>
+          <a:bodyPr/>
+          <a:lstStyle/>
+          <a:p>
+            <a:endParaRPr lang="es-ES"/>
+          </a:p>
+        </p:txBody>
       </p:sp>
       <p:sp>
         <p:nvSpPr>
@@ -11816,7 +11931,7 @@
           <a:bodyPr wrap="square" rtlCol="0" anchor="ctr"/>
           <a:lstStyle/>
           <a:p>
-            <a:pPr indent="0" marL="0">
+            <a:pPr marL="0" indent="0">
               <a:buNone/>
             </a:pPr>
             <a:r>
@@ -11855,7 +11970,7 @@
           <a:bodyPr wrap="square" rtlCol="0" anchor="ctr"/>
           <a:lstStyle/>
           <a:p>
-            <a:pPr algn="r" indent="0" marL="0">
+            <a:pPr marL="0" indent="0" algn="r">
               <a:buNone/>
             </a:pPr>
             <a:r>
@@ -11958,6 +12073,13 @@
             <a:prstDash val="solid"/>
           </a:ln>
         </p:spPr>
+        <p:txBody>
+          <a:bodyPr/>
+          <a:lstStyle/>
+          <a:p>
+            <a:endParaRPr lang="es-ES"/>
+          </a:p>
+        </p:txBody>
       </p:sp>
       <p:sp>
         <p:nvSpPr>
@@ -11980,7 +12102,7 @@
           <a:bodyPr wrap="square" rtlCol="0" anchor="ctr"/>
           <a:lstStyle/>
           <a:p>
-            <a:pPr indent="0" marL="0">
+            <a:pPr marL="0" indent="0">
               <a:buNone/>
             </a:pPr>
             <a:r>
@@ -12047,6 +12169,13 @@
             <a:prstDash val="solid"/>
           </a:ln>
         </p:spPr>
+        <p:txBody>
+          <a:bodyPr/>
+          <a:lstStyle/>
+          <a:p>
+            <a:endParaRPr lang="es-ES"/>
+          </a:p>
+        </p:txBody>
       </p:sp>
       <p:sp>
         <p:nvSpPr>
@@ -12069,7 +12198,7 @@
           <a:bodyPr wrap="square" rtlCol="0" anchor="ctr"/>
           <a:lstStyle/>
           <a:p>
-            <a:pPr indent="0" marL="0">
+            <a:pPr marL="0" indent="0">
               <a:buNone/>
             </a:pPr>
             <a:r>
@@ -12108,7 +12237,7 @@
           <a:bodyPr wrap="square" rtlCol="0" anchor="ctr"/>
           <a:lstStyle/>
           <a:p>
-            <a:pPr algn="r" indent="0" marL="0">
+            <a:pPr marL="0" indent="0" algn="r">
               <a:buNone/>
             </a:pPr>
             <a:r>
@@ -12147,7 +12276,7 @@
           <a:bodyPr wrap="square" rtlCol="0" anchor="t"/>
           <a:lstStyle/>
           <a:p>
-            <a:pPr indent="0" marL="0">
+            <a:pPr marL="0" indent="0">
               <a:buNone/>
             </a:pPr>
             <a:r>
@@ -12167,7 +12296,7 @@
       </p:sp>
       <p:graphicFrame>
         <p:nvGraphicFramePr>
-          <p:cNvPr id="5" name="Table 0"/>
+          <p:cNvPr id="6" name="Table 0"/>
           <p:cNvGraphicFramePr>
             <a:graphicFrameLocks noGrp="1"/>
           </p:cNvGraphicFramePr>
@@ -12181,15 +12310,27 @@
         </p:nvGraphicFramePr>
         <p:xfrm>
           <a:off x="548640" y="2194560"/>
-          <a:ext cx="11091672" cy="914400"/>
+          <a:ext cx="11091672" cy="3657600"/>
         </p:xfrm>
         <a:graphic>
           <a:graphicData uri="http://schemas.openxmlformats.org/drawingml/2006/table">
             <a:tbl>
               <a:tblPr/>
               <a:tblGrid>
-                <a:gridCol w="2772918"/>
-                <a:gridCol w="8318754"/>
+                <a:gridCol w="2772918">
+                  <a:extLst>
+                    <a:ext uri="{9D8B030D-6E8A-4147-A177-3AD203B41FA5}">
+                      <a16:colId xmlns:a16="http://schemas.microsoft.com/office/drawing/2014/main" val="20000"/>
+                    </a:ext>
+                  </a:extLst>
+                </a:gridCol>
+                <a:gridCol w="8318754">
+                  <a:extLst>
+                    <a:ext uri="{9D8B030D-6E8A-4147-A177-3AD203B41FA5}">
+                      <a16:colId xmlns:a16="http://schemas.microsoft.com/office/drawing/2014/main" val="20001"/>
+                    </a:ext>
+                  </a:extLst>
+                </a:gridCol>
               </a:tblGrid>
               <a:tr h="914400">
                 <a:tc>
@@ -12197,7 +12338,7 @@
                     <a:bodyPr/>
                     <a:lstStyle/>
                     <a:p>
-                      <a:pPr algn="ctr" indent="0" marL="0">
+                      <a:pPr marL="0" indent="0" algn="ctr">
                         <a:buNone/>
                       </a:pPr>
                       <a:r>
@@ -12218,7 +12359,7 @@
                       </a:endParaRPr>
                     </a:p>
                   </a:txBody>
-                  <a:tcPr marL="91440" marR="91440" marT="45720" marB="45720" anchor="ctr">
+                  <a:tcPr anchor="ctr">
                     <a:lnL w="12700" cap="flat" cmpd="sng" algn="ctr">
                       <a:solidFill>
                         <a:srgbClr val="EEEEEE"/>
@@ -12265,7 +12406,7 @@
                     <a:bodyPr/>
                     <a:lstStyle/>
                     <a:p>
-                      <a:pPr algn="ctr" indent="0" marL="0">
+                      <a:pPr marL="0" indent="0" algn="ctr">
                         <a:buNone/>
                       </a:pPr>
                       <a:r>
@@ -12286,7 +12427,7 @@
                       </a:endParaRPr>
                     </a:p>
                   </a:txBody>
-                  <a:tcPr marL="91440" marR="91440" marT="45720" marB="45720" anchor="ctr">
+                  <a:tcPr anchor="ctr">
                     <a:lnL w="12700" cap="flat" cmpd="sng" algn="ctr">
                       <a:solidFill>
                         <a:srgbClr val="EEEEEE"/>
@@ -12328,6 +12469,11 @@
                     </a:solidFill>
                   </a:tcPr>
                 </a:tc>
+                <a:extLst>
+                  <a:ext uri="{0D108BD9-81ED-4DB2-BD59-A6C34878D82A}">
+                    <a16:rowId xmlns:a16="http://schemas.microsoft.com/office/drawing/2014/main" val="10000"/>
+                  </a:ext>
+                </a:extLst>
               </a:tr>
               <a:tr h="914400">
                 <a:tc>
@@ -12335,7 +12481,7 @@
                     <a:bodyPr/>
                     <a:lstStyle/>
                     <a:p>
-                      <a:pPr indent="0" marL="0">
+                      <a:pPr marL="0" indent="0">
                         <a:buNone/>
                       </a:pPr>
                       <a:r>
@@ -12356,7 +12502,7 @@
                       </a:endParaRPr>
                     </a:p>
                   </a:txBody>
-                  <a:tcPr marL="91440" marR="91440" marT="45720" marB="45720" anchor="ctr">
+                  <a:tcPr anchor="ctr">
                     <a:lnL w="12700" cap="flat" cmpd="sng" algn="ctr">
                       <a:solidFill>
                         <a:srgbClr val="EEEEEE"/>
@@ -12403,7 +12549,7 @@
                     <a:bodyPr/>
                     <a:lstStyle/>
                     <a:p>
-                      <a:pPr indent="0" marL="0">
+                      <a:pPr marL="0" indent="0">
                         <a:buNone/>
                       </a:pPr>
                       <a:r>
@@ -12424,7 +12570,7 @@
                       </a:endParaRPr>
                     </a:p>
                   </a:txBody>
-                  <a:tcPr marL="91440" marR="91440" marT="45720" marB="45720" anchor="ctr">
+                  <a:tcPr anchor="ctr">
                     <a:lnL w="12700" cap="flat" cmpd="sng" algn="ctr">
                       <a:solidFill>
                         <a:srgbClr val="EEEEEE"/>
@@ -12466,6 +12612,11 @@
                     </a:solidFill>
                   </a:tcPr>
                 </a:tc>
+                <a:extLst>
+                  <a:ext uri="{0D108BD9-81ED-4DB2-BD59-A6C34878D82A}">
+                    <a16:rowId xmlns:a16="http://schemas.microsoft.com/office/drawing/2014/main" val="10001"/>
+                  </a:ext>
+                </a:extLst>
               </a:tr>
               <a:tr h="914400">
                 <a:tc>
@@ -12473,7 +12624,7 @@
                     <a:bodyPr/>
                     <a:lstStyle/>
                     <a:p>
-                      <a:pPr indent="0" marL="0">
+                      <a:pPr marL="0" indent="0">
                         <a:buNone/>
                       </a:pPr>
                       <a:r>
@@ -12494,7 +12645,7 @@
                       </a:endParaRPr>
                     </a:p>
                   </a:txBody>
-                  <a:tcPr marL="91440" marR="91440" marT="45720" marB="45720" anchor="ctr">
+                  <a:tcPr anchor="ctr">
                     <a:lnL w="12700" cap="flat" cmpd="sng" algn="ctr">
                       <a:solidFill>
                         <a:srgbClr val="EEEEEE"/>
@@ -12541,7 +12692,7 @@
                     <a:bodyPr/>
                     <a:lstStyle/>
                     <a:p>
-                      <a:pPr indent="0" marL="0">
+                      <a:pPr marL="0" indent="0">
                         <a:buNone/>
                       </a:pPr>
                       <a:r>
@@ -12562,7 +12713,7 @@
                       </a:endParaRPr>
                     </a:p>
                   </a:txBody>
-                  <a:tcPr marL="91440" marR="91440" marT="45720" marB="45720" anchor="ctr">
+                  <a:tcPr anchor="ctr">
                     <a:lnL w="12700" cap="flat" cmpd="sng" algn="ctr">
                       <a:solidFill>
                         <a:srgbClr val="EEEEEE"/>
@@ -12604,6 +12755,11 @@
                     </a:solidFill>
                   </a:tcPr>
                 </a:tc>
+                <a:extLst>
+                  <a:ext uri="{0D108BD9-81ED-4DB2-BD59-A6C34878D82A}">
+                    <a16:rowId xmlns:a16="http://schemas.microsoft.com/office/drawing/2014/main" val="10002"/>
+                  </a:ext>
+                </a:extLst>
               </a:tr>
               <a:tr h="914400">
                 <a:tc>
@@ -12611,7 +12767,7 @@
                     <a:bodyPr/>
                     <a:lstStyle/>
                     <a:p>
-                      <a:pPr indent="0" marL="0">
+                      <a:pPr marL="0" indent="0">
                         <a:buNone/>
                       </a:pPr>
                       <a:r>
@@ -12632,7 +12788,7 @@
                       </a:endParaRPr>
                     </a:p>
                   </a:txBody>
-                  <a:tcPr marL="91440" marR="91440" marT="45720" marB="45720" anchor="ctr">
+                  <a:tcPr anchor="ctr">
                     <a:lnL w="12700" cap="flat" cmpd="sng" algn="ctr">
                       <a:solidFill>
                         <a:srgbClr val="EEEEEE"/>
@@ -12679,7 +12835,7 @@
                     <a:bodyPr/>
                     <a:lstStyle/>
                     <a:p>
-                      <a:pPr indent="0" marL="0">
+                      <a:pPr marL="0" indent="0">
                         <a:buNone/>
                       </a:pPr>
                       <a:r>
@@ -12700,7 +12856,7 @@
                       </a:endParaRPr>
                     </a:p>
                   </a:txBody>
-                  <a:tcPr marL="91440" marR="91440" marT="45720" marB="45720" anchor="ctr">
+                  <a:tcPr anchor="ctr">
                     <a:lnL w="12700" cap="flat" cmpd="sng" algn="ctr">
                       <a:solidFill>
                         <a:srgbClr val="EEEEEE"/>
@@ -12742,6 +12898,11 @@
                     </a:solidFill>
                   </a:tcPr>
                 </a:tc>
+                <a:extLst>
+                  <a:ext uri="{0D108BD9-81ED-4DB2-BD59-A6C34878D82A}">
+                    <a16:rowId xmlns:a16="http://schemas.microsoft.com/office/drawing/2014/main" val="10003"/>
+                  </a:ext>
+                </a:extLst>
               </a:tr>
             </a:tbl>
           </a:graphicData>
@@ -12796,6 +12957,13 @@
             <a:prstDash val="solid"/>
           </a:ln>
         </p:spPr>
+        <p:txBody>
+          <a:bodyPr/>
+          <a:lstStyle/>
+          <a:p>
+            <a:endParaRPr lang="es-ES"/>
+          </a:p>
+        </p:txBody>
       </p:sp>
       <p:sp>
         <p:nvSpPr>
@@ -12818,7 +12986,7 @@
           <a:bodyPr wrap="square" rtlCol="0" anchor="ctr"/>
           <a:lstStyle/>
           <a:p>
-            <a:pPr indent="0" marL="0">
+            <a:pPr marL="0" indent="0">
               <a:buNone/>
             </a:pPr>
             <a:r>
@@ -12857,7 +13025,7 @@
           <a:bodyPr wrap="square" rtlCol="0" anchor="ctr"/>
           <a:lstStyle/>
           <a:p>
-            <a:pPr algn="r" indent="0" marL="0">
+            <a:pPr marL="0" indent="0" algn="r">
               <a:buNone/>
             </a:pPr>
             <a:r>
@@ -12899,6 +13067,13 @@
             <a:prstDash val="solid"/>
           </a:ln>
         </p:spPr>
+        <p:txBody>
+          <a:bodyPr/>
+          <a:lstStyle/>
+          <a:p>
+            <a:endParaRPr lang="es-ES"/>
+          </a:p>
+        </p:txBody>
       </p:sp>
       <p:sp>
         <p:nvSpPr>
@@ -12921,7 +13096,7 @@
           <a:bodyPr wrap="square" rtlCol="0" anchor="ctr"/>
           <a:lstStyle/>
           <a:p>
-            <a:pPr indent="0" marL="0">
+            <a:pPr marL="0" indent="0">
               <a:buNone/>
             </a:pPr>
             <a:r>
@@ -12988,6 +13163,13 @@
             <a:prstDash val="solid"/>
           </a:ln>
         </p:spPr>
+        <p:txBody>
+          <a:bodyPr/>
+          <a:lstStyle/>
+          <a:p>
+            <a:endParaRPr lang="es-ES"/>
+          </a:p>
+        </p:txBody>
       </p:sp>
       <p:sp>
         <p:nvSpPr>
@@ -13010,7 +13192,7 @@
           <a:bodyPr wrap="square" rtlCol="0" anchor="ctr"/>
           <a:lstStyle/>
           <a:p>
-            <a:pPr indent="0" marL="0">
+            <a:pPr marL="0" indent="0">
               <a:buNone/>
             </a:pPr>
             <a:r>
@@ -13049,7 +13231,7 @@
           <a:bodyPr wrap="square" rtlCol="0" anchor="ctr"/>
           <a:lstStyle/>
           <a:p>
-            <a:pPr algn="r" indent="0" marL="0">
+            <a:pPr marL="0" indent="0" algn="r">
               <a:buNone/>
             </a:pPr>
             <a:r>
@@ -13091,6 +13273,13 @@
             <a:prstDash val="solid"/>
           </a:ln>
         </p:spPr>
+        <p:txBody>
+          <a:bodyPr/>
+          <a:lstStyle/>
+          <a:p>
+            <a:endParaRPr lang="es-ES"/>
+          </a:p>
+        </p:txBody>
       </p:sp>
       <p:sp>
         <p:nvSpPr>
@@ -13113,7 +13302,7 @@
           <a:bodyPr wrap="square" rtlCol="0" anchor="t"/>
           <a:lstStyle/>
           <a:p>
-            <a:pPr indent="0" marL="0">
+            <a:pPr marL="0" indent="0">
               <a:buNone/>
             </a:pPr>
             <a:r>
@@ -13131,7 +13320,7 @@
             <a:endParaRPr lang="en-US" sz="2100" dirty="0"/>
           </a:p>
           <a:p>
-            <a:pPr indent="0" marL="0">
+            <a:pPr marL="0" indent="0">
               <a:buNone/>
             </a:pPr>
             <a:r>
@@ -13198,6 +13387,13 @@
             <a:prstDash val="solid"/>
           </a:ln>
         </p:spPr>
+        <p:txBody>
+          <a:bodyPr/>
+          <a:lstStyle/>
+          <a:p>
+            <a:endParaRPr lang="es-ES"/>
+          </a:p>
+        </p:txBody>
       </p:sp>
       <p:sp>
         <p:nvSpPr>
@@ -13220,7 +13416,7 @@
           <a:bodyPr wrap="square" rtlCol="0" anchor="ctr"/>
           <a:lstStyle/>
           <a:p>
-            <a:pPr indent="0" marL="0">
+            <a:pPr marL="0" indent="0">
               <a:buNone/>
             </a:pPr>
             <a:r>
@@ -13259,7 +13455,7 @@
           <a:bodyPr wrap="square" rtlCol="0" anchor="ctr"/>
           <a:lstStyle/>
           <a:p>
-            <a:pPr algn="r" indent="0" marL="0">
+            <a:pPr marL="0" indent="0" algn="r">
               <a:buNone/>
             </a:pPr>
             <a:r>
@@ -13450,6 +13646,13 @@
             <a:prstDash val="solid"/>
           </a:ln>
         </p:spPr>
+        <p:txBody>
+          <a:bodyPr/>
+          <a:lstStyle/>
+          <a:p>
+            <a:endParaRPr lang="es-ES"/>
+          </a:p>
+        </p:txBody>
       </p:sp>
       <p:sp>
         <p:nvSpPr>
@@ -13472,7 +13675,7 @@
           <a:bodyPr wrap="square" rtlCol="0" anchor="ctr"/>
           <a:lstStyle/>
           <a:p>
-            <a:pPr indent="0" marL="0">
+            <a:pPr marL="0" indent="0">
               <a:buNone/>
             </a:pPr>
             <a:r>
@@ -13511,7 +13714,7 @@
           <a:bodyPr wrap="square" rtlCol="0" anchor="ctr"/>
           <a:lstStyle/>
           <a:p>
-            <a:pPr algn="r" indent="0" marL="0">
+            <a:pPr marL="0" indent="0" algn="r">
               <a:buNone/>
             </a:pPr>
             <a:r>
@@ -13550,7 +13753,7 @@
           <a:bodyPr wrap="square" rtlCol="0" anchor="t"/>
           <a:lstStyle/>
           <a:p>
-            <a:pPr indent="0" marL="0">
+            <a:pPr marL="0" indent="0">
               <a:buNone/>
             </a:pPr>
             <a:r>
@@ -13592,6 +13795,13 @@
             <a:prstDash val="solid"/>
           </a:ln>
         </p:spPr>
+        <p:txBody>
+          <a:bodyPr/>
+          <a:lstStyle/>
+          <a:p>
+            <a:endParaRPr lang="es-ES"/>
+          </a:p>
+        </p:txBody>
       </p:sp>
       <p:sp>
         <p:nvSpPr>
@@ -13614,7 +13824,7 @@
           <a:bodyPr wrap="square" rtlCol="0" anchor="ctr"/>
           <a:lstStyle/>
           <a:p>
-            <a:pPr indent="0" marL="0">
+            <a:pPr marL="0" indent="0">
               <a:buNone/>
             </a:pPr>
             <a:r>
@@ -13681,6 +13891,13 @@
             <a:prstDash val="solid"/>
           </a:ln>
         </p:spPr>
+        <p:txBody>
+          <a:bodyPr/>
+          <a:lstStyle/>
+          <a:p>
+            <a:endParaRPr lang="es-ES"/>
+          </a:p>
+        </p:txBody>
       </p:sp>
       <p:sp>
         <p:nvSpPr>
@@ -13703,7 +13920,7 @@
           <a:bodyPr wrap="square" rtlCol="0" anchor="ctr"/>
           <a:lstStyle/>
           <a:p>
-            <a:pPr indent="0" marL="0">
+            <a:pPr marL="0" indent="0">
               <a:buNone/>
             </a:pPr>
             <a:r>
@@ -13742,7 +13959,7 @@
           <a:bodyPr wrap="square" rtlCol="0" anchor="ctr"/>
           <a:lstStyle/>
           <a:p>
-            <a:pPr algn="r" indent="0" marL="0">
+            <a:pPr marL="0" indent="0" algn="r">
               <a:buNone/>
             </a:pPr>
             <a:r>
@@ -13776,15 +13993,27 @@
         </p:nvGraphicFramePr>
         <p:xfrm>
           <a:off x="548640" y="1554480"/>
-          <a:ext cx="11091672" cy="914400"/>
+          <a:ext cx="11091672" cy="4343400"/>
         </p:xfrm>
         <a:graphic>
           <a:graphicData uri="http://schemas.openxmlformats.org/drawingml/2006/table">
             <a:tbl>
               <a:tblPr/>
               <a:tblGrid>
-                <a:gridCol w="3549335"/>
-                <a:gridCol w="7542337"/>
+                <a:gridCol w="3549335">
+                  <a:extLst>
+                    <a:ext uri="{9D8B030D-6E8A-4147-A177-3AD203B41FA5}">
+                      <a16:colId xmlns:a16="http://schemas.microsoft.com/office/drawing/2014/main" val="20000"/>
+                    </a:ext>
+                  </a:extLst>
+                </a:gridCol>
+                <a:gridCol w="7542337">
+                  <a:extLst>
+                    <a:ext uri="{9D8B030D-6E8A-4147-A177-3AD203B41FA5}">
+                      <a16:colId xmlns:a16="http://schemas.microsoft.com/office/drawing/2014/main" val="20001"/>
+                    </a:ext>
+                  </a:extLst>
+                </a:gridCol>
               </a:tblGrid>
               <a:tr h="868680">
                 <a:tc>
@@ -13792,7 +14021,7 @@
                     <a:bodyPr/>
                     <a:lstStyle/>
                     <a:p>
-                      <a:pPr algn="ctr" indent="0" marL="0">
+                      <a:pPr marL="0" indent="0" algn="ctr">
                         <a:buNone/>
                       </a:pPr>
                       <a:r>
@@ -13813,7 +14042,7 @@
                       </a:endParaRPr>
                     </a:p>
                   </a:txBody>
-                  <a:tcPr marL="91440" marR="91440" marT="45720" marB="45720" anchor="ctr">
+                  <a:tcPr anchor="ctr">
                     <a:lnL w="12700" cap="flat" cmpd="sng" algn="ctr">
                       <a:solidFill>
                         <a:srgbClr val="EEEEEE"/>
@@ -13860,7 +14089,7 @@
                     <a:bodyPr/>
                     <a:lstStyle/>
                     <a:p>
-                      <a:pPr algn="ctr" indent="0" marL="0">
+                      <a:pPr marL="0" indent="0" algn="ctr">
                         <a:buNone/>
                       </a:pPr>
                       <a:r>
@@ -13881,7 +14110,7 @@
                       </a:endParaRPr>
                     </a:p>
                   </a:txBody>
-                  <a:tcPr marL="91440" marR="91440" marT="45720" marB="45720" anchor="ctr">
+                  <a:tcPr anchor="ctr">
                     <a:lnL w="12700" cap="flat" cmpd="sng" algn="ctr">
                       <a:solidFill>
                         <a:srgbClr val="EEEEEE"/>
@@ -13923,6 +14152,11 @@
                     </a:solidFill>
                   </a:tcPr>
                 </a:tc>
+                <a:extLst>
+                  <a:ext uri="{0D108BD9-81ED-4DB2-BD59-A6C34878D82A}">
+                    <a16:rowId xmlns:a16="http://schemas.microsoft.com/office/drawing/2014/main" val="10000"/>
+                  </a:ext>
+                </a:extLst>
               </a:tr>
               <a:tr h="868680">
                 <a:tc>
@@ -13930,7 +14164,7 @@
                     <a:bodyPr/>
                     <a:lstStyle/>
                     <a:p>
-                      <a:pPr indent="0" marL="0">
+                      <a:pPr marL="0" indent="0">
                         <a:buNone/>
                       </a:pPr>
                       <a:r>
@@ -13951,7 +14185,7 @@
                       </a:endParaRPr>
                     </a:p>
                   </a:txBody>
-                  <a:tcPr marL="91440" marR="91440" marT="45720" marB="45720" anchor="ctr">
+                  <a:tcPr anchor="ctr">
                     <a:lnL w="12700" cap="flat" cmpd="sng" algn="ctr">
                       <a:solidFill>
                         <a:srgbClr val="EEEEEE"/>
@@ -13998,7 +14232,7 @@
                     <a:bodyPr/>
                     <a:lstStyle/>
                     <a:p>
-                      <a:pPr indent="0" marL="0">
+                      <a:pPr marL="0" indent="0">
                         <a:buNone/>
                       </a:pPr>
                       <a:r>
@@ -14019,7 +14253,7 @@
                       </a:endParaRPr>
                     </a:p>
                   </a:txBody>
-                  <a:tcPr marL="91440" marR="91440" marT="45720" marB="45720" anchor="ctr">
+                  <a:tcPr anchor="ctr">
                     <a:lnL w="12700" cap="flat" cmpd="sng" algn="ctr">
                       <a:solidFill>
                         <a:srgbClr val="EEEEEE"/>
@@ -14061,6 +14295,11 @@
                     </a:solidFill>
                   </a:tcPr>
                 </a:tc>
+                <a:extLst>
+                  <a:ext uri="{0D108BD9-81ED-4DB2-BD59-A6C34878D82A}">
+                    <a16:rowId xmlns:a16="http://schemas.microsoft.com/office/drawing/2014/main" val="10001"/>
+                  </a:ext>
+                </a:extLst>
               </a:tr>
               <a:tr h="868680">
                 <a:tc>
@@ -14068,7 +14307,7 @@
                     <a:bodyPr/>
                     <a:lstStyle/>
                     <a:p>
-                      <a:pPr indent="0" marL="0">
+                      <a:pPr marL="0" indent="0">
                         <a:buNone/>
                       </a:pPr>
                       <a:r>
@@ -14089,7 +14328,7 @@
                       </a:endParaRPr>
                     </a:p>
                   </a:txBody>
-                  <a:tcPr marL="91440" marR="91440" marT="45720" marB="45720" anchor="ctr">
+                  <a:tcPr anchor="ctr">
                     <a:lnL w="12700" cap="flat" cmpd="sng" algn="ctr">
                       <a:solidFill>
                         <a:srgbClr val="EEEEEE"/>
@@ -14136,7 +14375,7 @@
                     <a:bodyPr/>
                     <a:lstStyle/>
                     <a:p>
-                      <a:pPr indent="0" marL="0">
+                      <a:pPr marL="0" indent="0">
                         <a:buNone/>
                       </a:pPr>
                       <a:r>
@@ -14157,7 +14396,7 @@
                       </a:endParaRPr>
                     </a:p>
                   </a:txBody>
-                  <a:tcPr marL="91440" marR="91440" marT="45720" marB="45720" anchor="ctr">
+                  <a:tcPr anchor="ctr">
                     <a:lnL w="12700" cap="flat" cmpd="sng" algn="ctr">
                       <a:solidFill>
                         <a:srgbClr val="EEEEEE"/>
@@ -14199,6 +14438,11 @@
                     </a:solidFill>
                   </a:tcPr>
                 </a:tc>
+                <a:extLst>
+                  <a:ext uri="{0D108BD9-81ED-4DB2-BD59-A6C34878D82A}">
+                    <a16:rowId xmlns:a16="http://schemas.microsoft.com/office/drawing/2014/main" val="10002"/>
+                  </a:ext>
+                </a:extLst>
               </a:tr>
               <a:tr h="868680">
                 <a:tc>
@@ -14206,7 +14450,7 @@
                     <a:bodyPr/>
                     <a:lstStyle/>
                     <a:p>
-                      <a:pPr indent="0" marL="0">
+                      <a:pPr marL="0" indent="0">
                         <a:buNone/>
                       </a:pPr>
                       <a:r>
@@ -14227,7 +14471,7 @@
                       </a:endParaRPr>
                     </a:p>
                   </a:txBody>
-                  <a:tcPr marL="91440" marR="91440" marT="45720" marB="45720" anchor="ctr">
+                  <a:tcPr anchor="ctr">
                     <a:lnL w="12700" cap="flat" cmpd="sng" algn="ctr">
                       <a:solidFill>
                         <a:srgbClr val="EEEEEE"/>
@@ -14274,7 +14518,7 @@
                     <a:bodyPr/>
                     <a:lstStyle/>
                     <a:p>
-                      <a:pPr indent="0" marL="0">
+                      <a:pPr marL="0" indent="0">
                         <a:buNone/>
                       </a:pPr>
                       <a:r>
@@ -14295,7 +14539,7 @@
                       </a:endParaRPr>
                     </a:p>
                   </a:txBody>
-                  <a:tcPr marL="91440" marR="91440" marT="45720" marB="45720" anchor="ctr">
+                  <a:tcPr anchor="ctr">
                     <a:lnL w="12700" cap="flat" cmpd="sng" algn="ctr">
                       <a:solidFill>
                         <a:srgbClr val="EEEEEE"/>
@@ -14337,6 +14581,11 @@
                     </a:solidFill>
                   </a:tcPr>
                 </a:tc>
+                <a:extLst>
+                  <a:ext uri="{0D108BD9-81ED-4DB2-BD59-A6C34878D82A}">
+                    <a16:rowId xmlns:a16="http://schemas.microsoft.com/office/drawing/2014/main" val="10003"/>
+                  </a:ext>
+                </a:extLst>
               </a:tr>
               <a:tr h="868680">
                 <a:tc>
@@ -14344,7 +14593,7 @@
                     <a:bodyPr/>
                     <a:lstStyle/>
                     <a:p>
-                      <a:pPr indent="0" marL="0">
+                      <a:pPr marL="0" indent="0">
                         <a:buNone/>
                       </a:pPr>
                       <a:r>
@@ -14365,7 +14614,7 @@
                       </a:endParaRPr>
                     </a:p>
                   </a:txBody>
-                  <a:tcPr marL="91440" marR="91440" marT="45720" marB="45720" anchor="ctr">
+                  <a:tcPr anchor="ctr">
                     <a:lnL w="12700" cap="flat" cmpd="sng" algn="ctr">
                       <a:solidFill>
                         <a:srgbClr val="EEEEEE"/>
@@ -14412,7 +14661,7 @@
                     <a:bodyPr/>
                     <a:lstStyle/>
                     <a:p>
-                      <a:pPr indent="0" marL="0">
+                      <a:pPr marL="0" indent="0">
                         <a:buNone/>
                       </a:pPr>
                       <a:r>
@@ -14433,7 +14682,7 @@
                       </a:endParaRPr>
                     </a:p>
                   </a:txBody>
-                  <a:tcPr marL="91440" marR="91440" marT="45720" marB="45720" anchor="ctr">
+                  <a:tcPr anchor="ctr">
                     <a:lnL w="12700" cap="flat" cmpd="sng" algn="ctr">
                       <a:solidFill>
                         <a:srgbClr val="EEEEEE"/>
@@ -14475,6 +14724,11 @@
                     </a:solidFill>
                   </a:tcPr>
                 </a:tc>
+                <a:extLst>
+                  <a:ext uri="{0D108BD9-81ED-4DB2-BD59-A6C34878D82A}">
+                    <a16:rowId xmlns:a16="http://schemas.microsoft.com/office/drawing/2014/main" val="10004"/>
+                  </a:ext>
+                </a:extLst>
               </a:tr>
             </a:tbl>
           </a:graphicData>
@@ -14781,4 +15035,319 @@
     </a:ext>
   </a:extLst>
 </a:theme>
+</file>
+
+<file path=ppt/theme/theme2.xml><?xml version="1.0" encoding="utf-8"?>
+<a:theme xmlns:a="http://schemas.openxmlformats.org/drawingml/2006/main" name="Tema de Office">
+  <a:themeElements>
+    <a:clrScheme name="Office">
+      <a:dk1>
+        <a:sysClr val="windowText" lastClr="000000"/>
+      </a:dk1>
+      <a:lt1>
+        <a:sysClr val="window" lastClr="FFFFFF"/>
+      </a:lt1>
+      <a:dk2>
+        <a:srgbClr val="0E2841"/>
+      </a:dk2>
+      <a:lt2>
+        <a:srgbClr val="E8E8E8"/>
+      </a:lt2>
+      <a:accent1>
+        <a:srgbClr val="156082"/>
+      </a:accent1>
+      <a:accent2>
+        <a:srgbClr val="E97132"/>
+      </a:accent2>
+      <a:accent3>
+        <a:srgbClr val="196B24"/>
+      </a:accent3>
+      <a:accent4>
+        <a:srgbClr val="0F9ED5"/>
+      </a:accent4>
+      <a:accent5>
+        <a:srgbClr val="A02B93"/>
+      </a:accent5>
+      <a:accent6>
+        <a:srgbClr val="4EA72E"/>
+      </a:accent6>
+      <a:hlink>
+        <a:srgbClr val="467886"/>
+      </a:hlink>
+      <a:folHlink>
+        <a:srgbClr val="96607D"/>
+      </a:folHlink>
+    </a:clrScheme>
+    <a:fontScheme name="Office">
+      <a:majorFont>
+        <a:latin typeface="Aptos Display" panose="02110004020202020204"/>
+        <a:ea typeface=""/>
+        <a:cs typeface=""/>
+        <a:font script="Jpan" typeface="游ゴシック Light"/>
+        <a:font script="Hang" typeface="맑은 고딕"/>
+        <a:font script="Hans" typeface="等线 Light"/>
+        <a:font script="Hant" typeface="新細明體"/>
+        <a:font script="Arab" typeface="Times New Roman"/>
+        <a:font script="Hebr" typeface="Times New Roman"/>
+        <a:font script="Thai" typeface="Angsana New"/>
+        <a:font script="Ethi" typeface="Nyala"/>
+        <a:font script="Beng" typeface="Vrinda"/>
+        <a:font script="Gujr" typeface="Shruti"/>
+        <a:font script="Khmr" typeface="MoolBoran"/>
+        <a:font script="Knda" typeface="Tunga"/>
+        <a:font script="Guru" typeface="Raavi"/>
+        <a:font script="Cans" typeface="Euphemia"/>
+        <a:font script="Cher" typeface="Plantagenet Cherokee"/>
+        <a:font script="Yiii" typeface="Microsoft Yi Baiti"/>
+        <a:font script="Tibt" typeface="Microsoft Himalaya"/>
+        <a:font script="Thaa" typeface="MV Boli"/>
+        <a:font script="Deva" typeface="Mangal"/>
+        <a:font script="Telu" typeface="Gautami"/>
+        <a:font script="Taml" typeface="Latha"/>
+        <a:font script="Syrc" typeface="Estrangelo Edessa"/>
+        <a:font script="Orya" typeface="Kalinga"/>
+        <a:font script="Mlym" typeface="Kartika"/>
+        <a:font script="Laoo" typeface="DokChampa"/>
+        <a:font script="Sinh" typeface="Iskoola Pota"/>
+        <a:font script="Mong" typeface="Mongolian Baiti"/>
+        <a:font script="Viet" typeface="Times New Roman"/>
+        <a:font script="Uigh" typeface="Microsoft Uighur"/>
+        <a:font script="Geor" typeface="Sylfaen"/>
+        <a:font script="Armn" typeface="Arial"/>
+        <a:font script="Bugi" typeface="Leelawadee UI"/>
+        <a:font script="Bopo" typeface="Microsoft JhengHei"/>
+        <a:font script="Java" typeface="Javanese Text"/>
+        <a:font script="Lisu" typeface="Segoe UI"/>
+        <a:font script="Mymr" typeface="Myanmar Text"/>
+        <a:font script="Nkoo" typeface="Ebrima"/>
+        <a:font script="Olck" typeface="Nirmala UI"/>
+        <a:font script="Osma" typeface="Ebrima"/>
+        <a:font script="Phag" typeface="Phagspa"/>
+        <a:font script="Syrn" typeface="Estrangelo Edessa"/>
+        <a:font script="Syrj" typeface="Estrangelo Edessa"/>
+        <a:font script="Syre" typeface="Estrangelo Edessa"/>
+        <a:font script="Sora" typeface="Nirmala UI"/>
+        <a:font script="Tale" typeface="Microsoft Tai Le"/>
+        <a:font script="Talu" typeface="Microsoft New Tai Lue"/>
+        <a:font script="Tfng" typeface="Ebrima"/>
+      </a:majorFont>
+      <a:minorFont>
+        <a:latin typeface="Aptos" panose="02110004020202020204"/>
+        <a:ea typeface=""/>
+        <a:cs typeface=""/>
+        <a:font script="Jpan" typeface="游ゴシック"/>
+        <a:font script="Hang" typeface="맑은 고딕"/>
+        <a:font script="Hans" typeface="等线"/>
+        <a:font script="Hant" typeface="新細明體"/>
+        <a:font script="Arab" typeface="Arial"/>
+        <a:font script="Hebr" typeface="Arial"/>
+        <a:font script="Thai" typeface="Cordia New"/>
+        <a:font script="Ethi" typeface="Nyala"/>
+        <a:font script="Beng" typeface="Vrinda"/>
+        <a:font script="Gujr" typeface="Shruti"/>
+        <a:font script="Khmr" typeface="DaunPenh"/>
+        <a:font script="Knda" typeface="Tunga"/>
+        <a:font script="Guru" typeface="Raavi"/>
+        <a:font script="Cans" typeface="Euphemia"/>
+        <a:font script="Cher" typeface="Plantagenet Cherokee"/>
+        <a:font script="Yiii" typeface="Microsoft Yi Baiti"/>
+        <a:font script="Tibt" typeface="Microsoft Himalaya"/>
+        <a:font script="Thaa" typeface="MV Boli"/>
+        <a:font script="Deva" typeface="Mangal"/>
+        <a:font script="Telu" typeface="Gautami"/>
+        <a:font script="Taml" typeface="Latha"/>
+        <a:font script="Syrc" typeface="Estrangelo Edessa"/>
+        <a:font script="Orya" typeface="Kalinga"/>
+        <a:font script="Mlym" typeface="Kartika"/>
+        <a:font script="Laoo" typeface="DokChampa"/>
+        <a:font script="Sinh" typeface="Iskoola Pota"/>
+        <a:font script="Mong" typeface="Mongolian Baiti"/>
+        <a:font script="Viet" typeface="Arial"/>
+        <a:font script="Uigh" typeface="Microsoft Uighur"/>
+        <a:font script="Geor" typeface="Sylfaen"/>
+        <a:font script="Armn" typeface="Arial"/>
+        <a:font script="Bugi" typeface="Leelawadee UI"/>
+        <a:font script="Bopo" typeface="Microsoft JhengHei"/>
+        <a:font script="Java" typeface="Javanese Text"/>
+        <a:font script="Lisu" typeface="Segoe UI"/>
+        <a:font script="Mymr" typeface="Myanmar Text"/>
+        <a:font script="Nkoo" typeface="Ebrima"/>
+        <a:font script="Olck" typeface="Nirmala UI"/>
+        <a:font script="Osma" typeface="Ebrima"/>
+        <a:font script="Phag" typeface="Phagspa"/>
+        <a:font script="Syrn" typeface="Estrangelo Edessa"/>
+        <a:font script="Syrj" typeface="Estrangelo Edessa"/>
+        <a:font script="Syre" typeface="Estrangelo Edessa"/>
+        <a:font script="Sora" typeface="Nirmala UI"/>
+        <a:font script="Tale" typeface="Microsoft Tai Le"/>
+        <a:font script="Talu" typeface="Microsoft New Tai Lue"/>
+        <a:font script="Tfng" typeface="Ebrima"/>
+      </a:minorFont>
+    </a:fontScheme>
+    <a:fmtScheme name="Office">
+      <a:fillStyleLst>
+        <a:solidFill>
+          <a:schemeClr val="phClr"/>
+        </a:solidFill>
+        <a:gradFill rotWithShape="1">
+          <a:gsLst>
+            <a:gs pos="0">
+              <a:schemeClr val="phClr">
+                <a:lumMod val="110000"/>
+                <a:satMod val="105000"/>
+                <a:tint val="67000"/>
+              </a:schemeClr>
+            </a:gs>
+            <a:gs pos="50000">
+              <a:schemeClr val="phClr">
+                <a:lumMod val="105000"/>
+                <a:satMod val="103000"/>
+                <a:tint val="73000"/>
+              </a:schemeClr>
+            </a:gs>
+            <a:gs pos="100000">
+              <a:schemeClr val="phClr">
+                <a:lumMod val="105000"/>
+                <a:satMod val="109000"/>
+                <a:tint val="81000"/>
+              </a:schemeClr>
+            </a:gs>
+          </a:gsLst>
+          <a:lin ang="5400000" scaled="0"/>
+        </a:gradFill>
+        <a:gradFill rotWithShape="1">
+          <a:gsLst>
+            <a:gs pos="0">
+              <a:schemeClr val="phClr">
+                <a:satMod val="103000"/>
+                <a:lumMod val="102000"/>
+                <a:tint val="94000"/>
+              </a:schemeClr>
+            </a:gs>
+            <a:gs pos="50000">
+              <a:schemeClr val="phClr">
+                <a:satMod val="110000"/>
+                <a:lumMod val="100000"/>
+                <a:shade val="100000"/>
+              </a:schemeClr>
+            </a:gs>
+            <a:gs pos="100000">
+              <a:schemeClr val="phClr">
+                <a:lumMod val="99000"/>
+                <a:satMod val="120000"/>
+                <a:shade val="78000"/>
+              </a:schemeClr>
+            </a:gs>
+          </a:gsLst>
+          <a:lin ang="5400000" scaled="0"/>
+        </a:gradFill>
+      </a:fillStyleLst>
+      <a:lnStyleLst>
+        <a:ln w="12700" cap="flat" cmpd="sng" algn="ctr">
+          <a:solidFill>
+            <a:schemeClr val="phClr"/>
+          </a:solidFill>
+          <a:prstDash val="solid"/>
+          <a:miter lim="800000"/>
+        </a:ln>
+        <a:ln w="19050" cap="flat" cmpd="sng" algn="ctr">
+          <a:solidFill>
+            <a:schemeClr val="phClr"/>
+          </a:solidFill>
+          <a:prstDash val="solid"/>
+          <a:miter lim="800000"/>
+        </a:ln>
+        <a:ln w="25400" cap="flat" cmpd="sng" algn="ctr">
+          <a:solidFill>
+            <a:schemeClr val="phClr"/>
+          </a:solidFill>
+          <a:prstDash val="solid"/>
+          <a:miter lim="800000"/>
+        </a:ln>
+      </a:lnStyleLst>
+      <a:effectStyleLst>
+        <a:effectStyle>
+          <a:effectLst/>
+        </a:effectStyle>
+        <a:effectStyle>
+          <a:effectLst/>
+        </a:effectStyle>
+        <a:effectStyle>
+          <a:effectLst>
+            <a:outerShdw blurRad="57150" dist="19050" dir="5400000" algn="ctr" rotWithShape="0">
+              <a:srgbClr val="000000">
+                <a:alpha val="63000"/>
+              </a:srgbClr>
+            </a:outerShdw>
+          </a:effectLst>
+        </a:effectStyle>
+      </a:effectStyleLst>
+      <a:bgFillStyleLst>
+        <a:solidFill>
+          <a:schemeClr val="phClr"/>
+        </a:solidFill>
+        <a:solidFill>
+          <a:schemeClr val="phClr">
+            <a:tint val="95000"/>
+            <a:satMod val="170000"/>
+          </a:schemeClr>
+        </a:solidFill>
+        <a:gradFill rotWithShape="1">
+          <a:gsLst>
+            <a:gs pos="0">
+              <a:schemeClr val="phClr">
+                <a:tint val="93000"/>
+                <a:satMod val="150000"/>
+                <a:shade val="98000"/>
+                <a:lumMod val="102000"/>
+              </a:schemeClr>
+            </a:gs>
+            <a:gs pos="50000">
+              <a:schemeClr val="phClr">
+                <a:tint val="98000"/>
+                <a:satMod val="130000"/>
+                <a:shade val="90000"/>
+                <a:lumMod val="103000"/>
+              </a:schemeClr>
+            </a:gs>
+            <a:gs pos="100000">
+              <a:schemeClr val="phClr">
+                <a:shade val="63000"/>
+                <a:satMod val="120000"/>
+              </a:schemeClr>
+            </a:gs>
+          </a:gsLst>
+          <a:lin ang="5400000" scaled="0"/>
+        </a:gradFill>
+      </a:bgFillStyleLst>
+    </a:fmtScheme>
+  </a:themeElements>
+  <a:objectDefaults>
+    <a:lnDef>
+      <a:spPr/>
+      <a:bodyPr/>
+      <a:lstStyle/>
+      <a:style>
+        <a:lnRef idx="2">
+          <a:schemeClr val="accent1"/>
+        </a:lnRef>
+        <a:fillRef idx="0">
+          <a:schemeClr val="accent1"/>
+        </a:fillRef>
+        <a:effectRef idx="1">
+          <a:schemeClr val="accent1"/>
+        </a:effectRef>
+        <a:fontRef idx="minor">
+          <a:schemeClr val="tx1"/>
+        </a:fontRef>
+      </a:style>
+    </a:lnDef>
+  </a:objectDefaults>
+  <a:extraClrSchemeLst/>
+  <a:extLst>
+    <a:ext uri="{05A4C25C-085E-4340-85A3-A5531E510DB2}">
+      <thm15:themeFamily xmlns:thm15="http://schemas.microsoft.com/office/thememl/2012/main" name="Office Theme" id="{2E142A2C-CD16-42D6-873A-C26D2A0506FA}" vid="{1BDDFF52-6CD6-40A5-AB3C-68EB2F1E4D0A}"/>
+    </a:ext>
+  </a:extLst>
+</a:theme>
 </file>
</xml_diff>